<commit_message>
Add Sector column to both deal tables
Sector sits between Company and Stage in Japan and Korea tables, with
column widths rebalanced so headers and placeholders stay on one line.

Co-Authored-By: Claude Fable 5 <noreply@anthropic.com>
Claude-Session: https://claude.ai/code/session_01Egzj3n6LAZJYJNpNFgwsPm
</commit_message>
<xml_diff>
--- a/deal-status-onepager/US-Investment-Accelerator-Deal-Status.pptx
+++ b/deal-status-onepager/US-Investment-Accelerator-Deal-Status.pptx
@@ -503,7 +503,7 @@
             <a:r>
               <a:rPr lang="en-US" dirty="0"/>
               <a:t>FILL-IN GUIDE
-1. Type over every gray/placeholder value: Company 1-19, the $X.X B deal sizes (all in billions), First Last (owner's rep), the summary tiles, and the two '$XX.X B total' figures next to JAPAN and KOREA.
+1. Type over every gray/placeholder value: Company 1-19, Sector, the $X.X B deal sizes (all in billions), First Last (owner's rep), the summary tiles, and the two '$XX.X B total' figures next to JAPAN and KOREA.
 2. Stage tags are already set to the plan: Japan = 6 Announced, 3 Consultation, 4 Active. Korea = 3 Consultation, 3 Active (none announced). To change one anyway, delete it and Ctrl/Cmd-drag a spare tag from the right of the page into place. The spares sit off the page and never print.
 3. Add/remove rows: click in a table, use Table Layout &gt; Insert/Delete Rows. If you change row counts, drag the tags to keep them aligned with their rows, and update the counts in the summary strip.
 4. Rows are grouped by stage: Announced first, then Consultation, then Active.
@@ -1972,7 +1972,7 @@
         </p:nvSpPr>
         <p:spPr>
           <a:xfrm>
-            <a:off x="3054096" y="2171700"/>
+            <a:off x="2761488" y="2171700"/>
             <a:ext cx="2743200" cy="201168"/>
           </a:xfrm>
           <a:prstGeom prst="rect">
@@ -2026,7 +2026,7 @@
         <p:spPr>
           <a:xfrm>
             <a:off x="384048" y="2459736"/>
-            <a:ext cx="5413248" cy="25603"/>
+            <a:ext cx="5120640" cy="25603"/>
           </a:xfrm>
           <a:prstGeom prst="rect">
             <a:avLst/>
@@ -2053,17 +2053,18 @@
         </p:nvGraphicFramePr>
         <p:xfrm>
           <a:off x="384048" y="2569464"/>
-          <a:ext cx="5413248" cy="914400"/>
+          <a:ext cx="5120640" cy="914400"/>
         </p:xfrm>
         <a:graphic>
           <a:graphicData uri="http://schemas.openxmlformats.org/drawingml/2006/table">
             <a:tbl>
               <a:tblPr/>
               <a:tblGrid>
-                <a:gridCol w="1847088"/>
-                <a:gridCol w="1170432"/>
-                <a:gridCol w="841248"/>
-                <a:gridCol w="1554480"/>
+                <a:gridCol w="1298448"/>
+                <a:gridCol w="896112"/>
+                <a:gridCol w="1097280"/>
+                <a:gridCol w="731520"/>
+                <a:gridCol w="1097280"/>
               </a:tblGrid>
               <a:tr h="256032">
                 <a:tc>
@@ -2075,7 +2076,7 @@
                         <a:buNone/>
                       </a:pPr>
                       <a:r>
-                        <a:rPr lang="en-US" sz="800" b="1" spc="100" kern="0" dirty="0">
+                        <a:rPr lang="en-US" sz="800" b="1" spc="50" kern="0" dirty="0">
                           <a:solidFill>
                             <a:srgbClr val="898781"/>
                           </a:solidFill>
@@ -2122,7 +2123,54 @@
                         <a:buNone/>
                       </a:pPr>
                       <a:r>
-                        <a:rPr lang="en-US" sz="800" b="1" spc="100" kern="0" dirty="0">
+                        <a:rPr lang="en-US" sz="800" b="1" spc="50" kern="0" dirty="0">
+                          <a:solidFill>
+                            <a:srgbClr val="898781"/>
+                          </a:solidFill>
+                          <a:latin typeface="Arial" pitchFamily="34" charset="0"/>
+                          <a:ea typeface="Arial" pitchFamily="34" charset="-122"/>
+                          <a:cs typeface="Arial" pitchFamily="34" charset="-120"/>
+                        </a:rPr>
+                        <a:t>SECTOR</a:t>
+                      </a:r>
+                      <a:endParaRPr lang="en-US" sz="800" dirty="0">
+                        <a:latin typeface="Arial" charset="0"/>
+                        <a:ea typeface="Arial" charset="0"/>
+                        <a:cs typeface="Arial" charset="0"/>
+                      </a:endParaRPr>
+                    </a:p>
+                  </a:txBody>
+                  <a:tcPr marL="27432" marR="27432" marT="18288" marB="18288" anchor="ctr">
+                    <a:lnL w="0" cap="flat" cmpd="sng" algn="ctr">
+                      <a:noFill/>
+                    </a:lnL>
+                    <a:lnR w="0" cap="flat" cmpd="sng" algn="ctr">
+                      <a:noFill/>
+                    </a:lnR>
+                    <a:lnT w="0" cap="flat" cmpd="sng" algn="ctr">
+                      <a:noFill/>
+                    </a:lnT>
+                    <a:lnB w="15875" cap="flat" cmpd="sng" algn="ctr">
+                      <a:solidFill>
+                        <a:srgbClr val="E1E0D9"/>
+                      </a:solidFill>
+                      <a:prstDash val="solid"/>
+                      <a:round/>
+                      <a:headEnd type="none" w="med" len="med"/>
+                      <a:tailEnd type="none" w="med" len="med"/>
+                    </a:lnB>
+                  </a:tcPr>
+                </a:tc>
+                <a:tc>
+                  <a:txBody>
+                    <a:bodyPr/>
+                    <a:lstStyle/>
+                    <a:p>
+                      <a:pPr indent="0" marL="0">
+                        <a:buNone/>
+                      </a:pPr>
+                      <a:r>
+                        <a:rPr lang="en-US" sz="800" b="1" spc="50" kern="0" dirty="0">
                           <a:solidFill>
                             <a:srgbClr val="898781"/>
                           </a:solidFill>
@@ -2169,7 +2217,7 @@
                         <a:buNone/>
                       </a:pPr>
                       <a:r>
-                        <a:rPr lang="en-US" sz="800" b="1" spc="100" kern="0" dirty="0">
+                        <a:rPr lang="en-US" sz="800" b="1" spc="50" kern="0" dirty="0">
                           <a:solidFill>
                             <a:srgbClr val="898781"/>
                           </a:solidFill>
@@ -2186,7 +2234,7 @@
                       </a:endParaRPr>
                     </a:p>
                   </a:txBody>
-                  <a:tcPr marL="27432" marR="91440" marT="18288" marB="18288" anchor="ctr">
+                  <a:tcPr marL="27432" marR="73152" marT="18288" marB="18288" anchor="ctr">
                     <a:lnL w="0" cap="flat" cmpd="sng" algn="ctr">
                       <a:noFill/>
                     </a:lnL>
@@ -2216,7 +2264,7 @@
                         <a:buNone/>
                       </a:pPr>
                       <a:r>
-                        <a:rPr lang="en-US" sz="800" b="1" spc="100" kern="0" dirty="0">
+                        <a:rPr lang="en-US" sz="800" b="1" spc="50" kern="0" dirty="0">
                           <a:solidFill>
                             <a:srgbClr val="898781"/>
                           </a:solidFill>
@@ -2311,6 +2359,53 @@
                       <a:pPr indent="0" marL="0">
                         <a:buNone/>
                       </a:pPr>
+                      <a:r>
+                        <a:rPr lang="en-US" sz="900" dirty="0">
+                          <a:solidFill>
+                            <a:srgbClr val="52514E"/>
+                          </a:solidFill>
+                          <a:latin typeface="Arial" pitchFamily="34" charset="0"/>
+                          <a:ea typeface="Arial" pitchFamily="34" charset="-122"/>
+                          <a:cs typeface="Arial" pitchFamily="34" charset="-120"/>
+                        </a:rPr>
+                        <a:t>Sector</a:t>
+                      </a:r>
+                      <a:endParaRPr lang="en-US" sz="900" dirty="0">
+                        <a:latin typeface="Arial" charset="0"/>
+                        <a:ea typeface="Arial" charset="0"/>
+                        <a:cs typeface="Arial" charset="0"/>
+                      </a:endParaRPr>
+                    </a:p>
+                  </a:txBody>
+                  <a:tcPr marL="27432" marR="27432" marT="18288" marB="18288" anchor="ctr">
+                    <a:lnL w="0" cap="flat" cmpd="sng" algn="ctr">
+                      <a:noFill/>
+                    </a:lnL>
+                    <a:lnR w="0" cap="flat" cmpd="sng" algn="ctr">
+                      <a:noFill/>
+                    </a:lnR>
+                    <a:lnT w="0" cap="flat" cmpd="sng" algn="ctr">
+                      <a:noFill/>
+                    </a:lnT>
+                    <a:lnB w="9525" cap="flat" cmpd="sng" algn="ctr">
+                      <a:solidFill>
+                        <a:srgbClr val="E1E0D9"/>
+                      </a:solidFill>
+                      <a:prstDash val="solid"/>
+                      <a:round/>
+                      <a:headEnd type="none" w="med" len="med"/>
+                      <a:tailEnd type="none" w="med" len="med"/>
+                    </a:lnB>
+                  </a:tcPr>
+                </a:tc>
+                <a:tc>
+                  <a:txBody>
+                    <a:bodyPr/>
+                    <a:lstStyle/>
+                    <a:p>
+                      <a:pPr indent="0" marL="0">
+                        <a:buNone/>
+                      </a:pPr>
                       <a:endParaRPr lang="en-US" sz="950" dirty="0">
                         <a:latin typeface="Arial" charset="0"/>
                         <a:ea typeface="Arial" charset="0"/>
@@ -2490,6 +2585,53 @@
                       <a:pPr indent="0" marL="0">
                         <a:buNone/>
                       </a:pPr>
+                      <a:r>
+                        <a:rPr lang="en-US" sz="900" dirty="0">
+                          <a:solidFill>
+                            <a:srgbClr val="52514E"/>
+                          </a:solidFill>
+                          <a:latin typeface="Arial" pitchFamily="34" charset="0"/>
+                          <a:ea typeface="Arial" pitchFamily="34" charset="-122"/>
+                          <a:cs typeface="Arial" pitchFamily="34" charset="-120"/>
+                        </a:rPr>
+                        <a:t>Sector</a:t>
+                      </a:r>
+                      <a:endParaRPr lang="en-US" sz="900" dirty="0">
+                        <a:latin typeface="Arial" charset="0"/>
+                        <a:ea typeface="Arial" charset="0"/>
+                        <a:cs typeface="Arial" charset="0"/>
+                      </a:endParaRPr>
+                    </a:p>
+                  </a:txBody>
+                  <a:tcPr marL="27432" marR="27432" marT="18288" marB="18288" anchor="ctr">
+                    <a:lnL w="0" cap="flat" cmpd="sng" algn="ctr">
+                      <a:noFill/>
+                    </a:lnL>
+                    <a:lnR w="0" cap="flat" cmpd="sng" algn="ctr">
+                      <a:noFill/>
+                    </a:lnR>
+                    <a:lnT w="0" cap="flat" cmpd="sng" algn="ctr">
+                      <a:noFill/>
+                    </a:lnT>
+                    <a:lnB w="9525" cap="flat" cmpd="sng" algn="ctr">
+                      <a:solidFill>
+                        <a:srgbClr val="E1E0D9"/>
+                      </a:solidFill>
+                      <a:prstDash val="solid"/>
+                      <a:round/>
+                      <a:headEnd type="none" w="med" len="med"/>
+                      <a:tailEnd type="none" w="med" len="med"/>
+                    </a:lnB>
+                  </a:tcPr>
+                </a:tc>
+                <a:tc>
+                  <a:txBody>
+                    <a:bodyPr/>
+                    <a:lstStyle/>
+                    <a:p>
+                      <a:pPr indent="0" marL="0">
+                        <a:buNone/>
+                      </a:pPr>
                       <a:endParaRPr lang="en-US" sz="950" dirty="0">
                         <a:latin typeface="Arial" charset="0"/>
                         <a:ea typeface="Arial" charset="0"/>
@@ -2669,6 +2811,53 @@
                       <a:pPr indent="0" marL="0">
                         <a:buNone/>
                       </a:pPr>
+                      <a:r>
+                        <a:rPr lang="en-US" sz="900" dirty="0">
+                          <a:solidFill>
+                            <a:srgbClr val="52514E"/>
+                          </a:solidFill>
+                          <a:latin typeface="Arial" pitchFamily="34" charset="0"/>
+                          <a:ea typeface="Arial" pitchFamily="34" charset="-122"/>
+                          <a:cs typeface="Arial" pitchFamily="34" charset="-120"/>
+                        </a:rPr>
+                        <a:t>Sector</a:t>
+                      </a:r>
+                      <a:endParaRPr lang="en-US" sz="900" dirty="0">
+                        <a:latin typeface="Arial" charset="0"/>
+                        <a:ea typeface="Arial" charset="0"/>
+                        <a:cs typeface="Arial" charset="0"/>
+                      </a:endParaRPr>
+                    </a:p>
+                  </a:txBody>
+                  <a:tcPr marL="27432" marR="27432" marT="18288" marB="18288" anchor="ctr">
+                    <a:lnL w="0" cap="flat" cmpd="sng" algn="ctr">
+                      <a:noFill/>
+                    </a:lnL>
+                    <a:lnR w="0" cap="flat" cmpd="sng" algn="ctr">
+                      <a:noFill/>
+                    </a:lnR>
+                    <a:lnT w="0" cap="flat" cmpd="sng" algn="ctr">
+                      <a:noFill/>
+                    </a:lnT>
+                    <a:lnB w="9525" cap="flat" cmpd="sng" algn="ctr">
+                      <a:solidFill>
+                        <a:srgbClr val="E1E0D9"/>
+                      </a:solidFill>
+                      <a:prstDash val="solid"/>
+                      <a:round/>
+                      <a:headEnd type="none" w="med" len="med"/>
+                      <a:tailEnd type="none" w="med" len="med"/>
+                    </a:lnB>
+                  </a:tcPr>
+                </a:tc>
+                <a:tc>
+                  <a:txBody>
+                    <a:bodyPr/>
+                    <a:lstStyle/>
+                    <a:p>
+                      <a:pPr indent="0" marL="0">
+                        <a:buNone/>
+                      </a:pPr>
                       <a:endParaRPr lang="en-US" sz="950" dirty="0">
                         <a:latin typeface="Arial" charset="0"/>
                         <a:ea typeface="Arial" charset="0"/>
@@ -2848,6 +3037,53 @@
                       <a:pPr indent="0" marL="0">
                         <a:buNone/>
                       </a:pPr>
+                      <a:r>
+                        <a:rPr lang="en-US" sz="900" dirty="0">
+                          <a:solidFill>
+                            <a:srgbClr val="52514E"/>
+                          </a:solidFill>
+                          <a:latin typeface="Arial" pitchFamily="34" charset="0"/>
+                          <a:ea typeface="Arial" pitchFamily="34" charset="-122"/>
+                          <a:cs typeface="Arial" pitchFamily="34" charset="-120"/>
+                        </a:rPr>
+                        <a:t>Sector</a:t>
+                      </a:r>
+                      <a:endParaRPr lang="en-US" sz="900" dirty="0">
+                        <a:latin typeface="Arial" charset="0"/>
+                        <a:ea typeface="Arial" charset="0"/>
+                        <a:cs typeface="Arial" charset="0"/>
+                      </a:endParaRPr>
+                    </a:p>
+                  </a:txBody>
+                  <a:tcPr marL="27432" marR="27432" marT="18288" marB="18288" anchor="ctr">
+                    <a:lnL w="0" cap="flat" cmpd="sng" algn="ctr">
+                      <a:noFill/>
+                    </a:lnL>
+                    <a:lnR w="0" cap="flat" cmpd="sng" algn="ctr">
+                      <a:noFill/>
+                    </a:lnR>
+                    <a:lnT w="0" cap="flat" cmpd="sng" algn="ctr">
+                      <a:noFill/>
+                    </a:lnT>
+                    <a:lnB w="9525" cap="flat" cmpd="sng" algn="ctr">
+                      <a:solidFill>
+                        <a:srgbClr val="E1E0D9"/>
+                      </a:solidFill>
+                      <a:prstDash val="solid"/>
+                      <a:round/>
+                      <a:headEnd type="none" w="med" len="med"/>
+                      <a:tailEnd type="none" w="med" len="med"/>
+                    </a:lnB>
+                  </a:tcPr>
+                </a:tc>
+                <a:tc>
+                  <a:txBody>
+                    <a:bodyPr/>
+                    <a:lstStyle/>
+                    <a:p>
+                      <a:pPr indent="0" marL="0">
+                        <a:buNone/>
+                      </a:pPr>
                       <a:endParaRPr lang="en-US" sz="950" dirty="0">
                         <a:latin typeface="Arial" charset="0"/>
                         <a:ea typeface="Arial" charset="0"/>
@@ -3027,6 +3263,53 @@
                       <a:pPr indent="0" marL="0">
                         <a:buNone/>
                       </a:pPr>
+                      <a:r>
+                        <a:rPr lang="en-US" sz="900" dirty="0">
+                          <a:solidFill>
+                            <a:srgbClr val="52514E"/>
+                          </a:solidFill>
+                          <a:latin typeface="Arial" pitchFamily="34" charset="0"/>
+                          <a:ea typeface="Arial" pitchFamily="34" charset="-122"/>
+                          <a:cs typeface="Arial" pitchFamily="34" charset="-120"/>
+                        </a:rPr>
+                        <a:t>Sector</a:t>
+                      </a:r>
+                      <a:endParaRPr lang="en-US" sz="900" dirty="0">
+                        <a:latin typeface="Arial" charset="0"/>
+                        <a:ea typeface="Arial" charset="0"/>
+                        <a:cs typeface="Arial" charset="0"/>
+                      </a:endParaRPr>
+                    </a:p>
+                  </a:txBody>
+                  <a:tcPr marL="27432" marR="27432" marT="18288" marB="18288" anchor="ctr">
+                    <a:lnL w="0" cap="flat" cmpd="sng" algn="ctr">
+                      <a:noFill/>
+                    </a:lnL>
+                    <a:lnR w="0" cap="flat" cmpd="sng" algn="ctr">
+                      <a:noFill/>
+                    </a:lnR>
+                    <a:lnT w="0" cap="flat" cmpd="sng" algn="ctr">
+                      <a:noFill/>
+                    </a:lnT>
+                    <a:lnB w="9525" cap="flat" cmpd="sng" algn="ctr">
+                      <a:solidFill>
+                        <a:srgbClr val="E1E0D9"/>
+                      </a:solidFill>
+                      <a:prstDash val="solid"/>
+                      <a:round/>
+                      <a:headEnd type="none" w="med" len="med"/>
+                      <a:tailEnd type="none" w="med" len="med"/>
+                    </a:lnB>
+                  </a:tcPr>
+                </a:tc>
+                <a:tc>
+                  <a:txBody>
+                    <a:bodyPr/>
+                    <a:lstStyle/>
+                    <a:p>
+                      <a:pPr indent="0" marL="0">
+                        <a:buNone/>
+                      </a:pPr>
                       <a:endParaRPr lang="en-US" sz="950" dirty="0">
                         <a:latin typeface="Arial" charset="0"/>
                         <a:ea typeface="Arial" charset="0"/>
@@ -3206,6 +3489,53 @@
                       <a:pPr indent="0" marL="0">
                         <a:buNone/>
                       </a:pPr>
+                      <a:r>
+                        <a:rPr lang="en-US" sz="900" dirty="0">
+                          <a:solidFill>
+                            <a:srgbClr val="52514E"/>
+                          </a:solidFill>
+                          <a:latin typeface="Arial" pitchFamily="34" charset="0"/>
+                          <a:ea typeface="Arial" pitchFamily="34" charset="-122"/>
+                          <a:cs typeface="Arial" pitchFamily="34" charset="-120"/>
+                        </a:rPr>
+                        <a:t>Sector</a:t>
+                      </a:r>
+                      <a:endParaRPr lang="en-US" sz="900" dirty="0">
+                        <a:latin typeface="Arial" charset="0"/>
+                        <a:ea typeface="Arial" charset="0"/>
+                        <a:cs typeface="Arial" charset="0"/>
+                      </a:endParaRPr>
+                    </a:p>
+                  </a:txBody>
+                  <a:tcPr marL="27432" marR="27432" marT="18288" marB="18288" anchor="ctr">
+                    <a:lnL w="0" cap="flat" cmpd="sng" algn="ctr">
+                      <a:noFill/>
+                    </a:lnL>
+                    <a:lnR w="0" cap="flat" cmpd="sng" algn="ctr">
+                      <a:noFill/>
+                    </a:lnR>
+                    <a:lnT w="0" cap="flat" cmpd="sng" algn="ctr">
+                      <a:noFill/>
+                    </a:lnT>
+                    <a:lnB w="9525" cap="flat" cmpd="sng" algn="ctr">
+                      <a:solidFill>
+                        <a:srgbClr val="E1E0D9"/>
+                      </a:solidFill>
+                      <a:prstDash val="solid"/>
+                      <a:round/>
+                      <a:headEnd type="none" w="med" len="med"/>
+                      <a:tailEnd type="none" w="med" len="med"/>
+                    </a:lnB>
+                  </a:tcPr>
+                </a:tc>
+                <a:tc>
+                  <a:txBody>
+                    <a:bodyPr/>
+                    <a:lstStyle/>
+                    <a:p>
+                      <a:pPr indent="0" marL="0">
+                        <a:buNone/>
+                      </a:pPr>
                       <a:endParaRPr lang="en-US" sz="950" dirty="0">
                         <a:latin typeface="Arial" charset="0"/>
                         <a:ea typeface="Arial" charset="0"/>
@@ -3385,6 +3715,53 @@
                       <a:pPr indent="0" marL="0">
                         <a:buNone/>
                       </a:pPr>
+                      <a:r>
+                        <a:rPr lang="en-US" sz="900" dirty="0">
+                          <a:solidFill>
+                            <a:srgbClr val="52514E"/>
+                          </a:solidFill>
+                          <a:latin typeface="Arial" pitchFamily="34" charset="0"/>
+                          <a:ea typeface="Arial" pitchFamily="34" charset="-122"/>
+                          <a:cs typeface="Arial" pitchFamily="34" charset="-120"/>
+                        </a:rPr>
+                        <a:t>Sector</a:t>
+                      </a:r>
+                      <a:endParaRPr lang="en-US" sz="900" dirty="0">
+                        <a:latin typeface="Arial" charset="0"/>
+                        <a:ea typeface="Arial" charset="0"/>
+                        <a:cs typeface="Arial" charset="0"/>
+                      </a:endParaRPr>
+                    </a:p>
+                  </a:txBody>
+                  <a:tcPr marL="27432" marR="27432" marT="18288" marB="18288" anchor="ctr">
+                    <a:lnL w="0" cap="flat" cmpd="sng" algn="ctr">
+                      <a:noFill/>
+                    </a:lnL>
+                    <a:lnR w="0" cap="flat" cmpd="sng" algn="ctr">
+                      <a:noFill/>
+                    </a:lnR>
+                    <a:lnT w="0" cap="flat" cmpd="sng" algn="ctr">
+                      <a:noFill/>
+                    </a:lnT>
+                    <a:lnB w="9525" cap="flat" cmpd="sng" algn="ctr">
+                      <a:solidFill>
+                        <a:srgbClr val="E1E0D9"/>
+                      </a:solidFill>
+                      <a:prstDash val="solid"/>
+                      <a:round/>
+                      <a:headEnd type="none" w="med" len="med"/>
+                      <a:tailEnd type="none" w="med" len="med"/>
+                    </a:lnB>
+                  </a:tcPr>
+                </a:tc>
+                <a:tc>
+                  <a:txBody>
+                    <a:bodyPr/>
+                    <a:lstStyle/>
+                    <a:p>
+                      <a:pPr indent="0" marL="0">
+                        <a:buNone/>
+                      </a:pPr>
                       <a:endParaRPr lang="en-US" sz="950" dirty="0">
                         <a:latin typeface="Arial" charset="0"/>
                         <a:ea typeface="Arial" charset="0"/>
@@ -3564,6 +3941,53 @@
                       <a:pPr indent="0" marL="0">
                         <a:buNone/>
                       </a:pPr>
+                      <a:r>
+                        <a:rPr lang="en-US" sz="900" dirty="0">
+                          <a:solidFill>
+                            <a:srgbClr val="52514E"/>
+                          </a:solidFill>
+                          <a:latin typeface="Arial" pitchFamily="34" charset="0"/>
+                          <a:ea typeface="Arial" pitchFamily="34" charset="-122"/>
+                          <a:cs typeface="Arial" pitchFamily="34" charset="-120"/>
+                        </a:rPr>
+                        <a:t>Sector</a:t>
+                      </a:r>
+                      <a:endParaRPr lang="en-US" sz="900" dirty="0">
+                        <a:latin typeface="Arial" charset="0"/>
+                        <a:ea typeface="Arial" charset="0"/>
+                        <a:cs typeface="Arial" charset="0"/>
+                      </a:endParaRPr>
+                    </a:p>
+                  </a:txBody>
+                  <a:tcPr marL="27432" marR="27432" marT="18288" marB="18288" anchor="ctr">
+                    <a:lnL w="0" cap="flat" cmpd="sng" algn="ctr">
+                      <a:noFill/>
+                    </a:lnL>
+                    <a:lnR w="0" cap="flat" cmpd="sng" algn="ctr">
+                      <a:noFill/>
+                    </a:lnR>
+                    <a:lnT w="0" cap="flat" cmpd="sng" algn="ctr">
+                      <a:noFill/>
+                    </a:lnT>
+                    <a:lnB w="9525" cap="flat" cmpd="sng" algn="ctr">
+                      <a:solidFill>
+                        <a:srgbClr val="E1E0D9"/>
+                      </a:solidFill>
+                      <a:prstDash val="solid"/>
+                      <a:round/>
+                      <a:headEnd type="none" w="med" len="med"/>
+                      <a:tailEnd type="none" w="med" len="med"/>
+                    </a:lnB>
+                  </a:tcPr>
+                </a:tc>
+                <a:tc>
+                  <a:txBody>
+                    <a:bodyPr/>
+                    <a:lstStyle/>
+                    <a:p>
+                      <a:pPr indent="0" marL="0">
+                        <a:buNone/>
+                      </a:pPr>
                       <a:endParaRPr lang="en-US" sz="950" dirty="0">
                         <a:latin typeface="Arial" charset="0"/>
                         <a:ea typeface="Arial" charset="0"/>
@@ -3743,6 +4167,53 @@
                       <a:pPr indent="0" marL="0">
                         <a:buNone/>
                       </a:pPr>
+                      <a:r>
+                        <a:rPr lang="en-US" sz="900" dirty="0">
+                          <a:solidFill>
+                            <a:srgbClr val="52514E"/>
+                          </a:solidFill>
+                          <a:latin typeface="Arial" pitchFamily="34" charset="0"/>
+                          <a:ea typeface="Arial" pitchFamily="34" charset="-122"/>
+                          <a:cs typeface="Arial" pitchFamily="34" charset="-120"/>
+                        </a:rPr>
+                        <a:t>Sector</a:t>
+                      </a:r>
+                      <a:endParaRPr lang="en-US" sz="900" dirty="0">
+                        <a:latin typeface="Arial" charset="0"/>
+                        <a:ea typeface="Arial" charset="0"/>
+                        <a:cs typeface="Arial" charset="0"/>
+                      </a:endParaRPr>
+                    </a:p>
+                  </a:txBody>
+                  <a:tcPr marL="27432" marR="27432" marT="18288" marB="18288" anchor="ctr">
+                    <a:lnL w="0" cap="flat" cmpd="sng" algn="ctr">
+                      <a:noFill/>
+                    </a:lnL>
+                    <a:lnR w="0" cap="flat" cmpd="sng" algn="ctr">
+                      <a:noFill/>
+                    </a:lnR>
+                    <a:lnT w="0" cap="flat" cmpd="sng" algn="ctr">
+                      <a:noFill/>
+                    </a:lnT>
+                    <a:lnB w="9525" cap="flat" cmpd="sng" algn="ctr">
+                      <a:solidFill>
+                        <a:srgbClr val="E1E0D9"/>
+                      </a:solidFill>
+                      <a:prstDash val="solid"/>
+                      <a:round/>
+                      <a:headEnd type="none" w="med" len="med"/>
+                      <a:tailEnd type="none" w="med" len="med"/>
+                    </a:lnB>
+                  </a:tcPr>
+                </a:tc>
+                <a:tc>
+                  <a:txBody>
+                    <a:bodyPr/>
+                    <a:lstStyle/>
+                    <a:p>
+                      <a:pPr indent="0" marL="0">
+                        <a:buNone/>
+                      </a:pPr>
                       <a:endParaRPr lang="en-US" sz="950" dirty="0">
                         <a:latin typeface="Arial" charset="0"/>
                         <a:ea typeface="Arial" charset="0"/>
@@ -3922,6 +4393,53 @@
                       <a:pPr indent="0" marL="0">
                         <a:buNone/>
                       </a:pPr>
+                      <a:r>
+                        <a:rPr lang="en-US" sz="900" dirty="0">
+                          <a:solidFill>
+                            <a:srgbClr val="52514E"/>
+                          </a:solidFill>
+                          <a:latin typeface="Arial" pitchFamily="34" charset="0"/>
+                          <a:ea typeface="Arial" pitchFamily="34" charset="-122"/>
+                          <a:cs typeface="Arial" pitchFamily="34" charset="-120"/>
+                        </a:rPr>
+                        <a:t>Sector</a:t>
+                      </a:r>
+                      <a:endParaRPr lang="en-US" sz="900" dirty="0">
+                        <a:latin typeface="Arial" charset="0"/>
+                        <a:ea typeface="Arial" charset="0"/>
+                        <a:cs typeface="Arial" charset="0"/>
+                      </a:endParaRPr>
+                    </a:p>
+                  </a:txBody>
+                  <a:tcPr marL="27432" marR="27432" marT="18288" marB="18288" anchor="ctr">
+                    <a:lnL w="0" cap="flat" cmpd="sng" algn="ctr">
+                      <a:noFill/>
+                    </a:lnL>
+                    <a:lnR w="0" cap="flat" cmpd="sng" algn="ctr">
+                      <a:noFill/>
+                    </a:lnR>
+                    <a:lnT w="0" cap="flat" cmpd="sng" algn="ctr">
+                      <a:noFill/>
+                    </a:lnT>
+                    <a:lnB w="9525" cap="flat" cmpd="sng" algn="ctr">
+                      <a:solidFill>
+                        <a:srgbClr val="E1E0D9"/>
+                      </a:solidFill>
+                      <a:prstDash val="solid"/>
+                      <a:round/>
+                      <a:headEnd type="none" w="med" len="med"/>
+                      <a:tailEnd type="none" w="med" len="med"/>
+                    </a:lnB>
+                  </a:tcPr>
+                </a:tc>
+                <a:tc>
+                  <a:txBody>
+                    <a:bodyPr/>
+                    <a:lstStyle/>
+                    <a:p>
+                      <a:pPr indent="0" marL="0">
+                        <a:buNone/>
+                      </a:pPr>
                       <a:endParaRPr lang="en-US" sz="950" dirty="0">
                         <a:latin typeface="Arial" charset="0"/>
                         <a:ea typeface="Arial" charset="0"/>
@@ -4101,6 +4619,53 @@
                       <a:pPr indent="0" marL="0">
                         <a:buNone/>
                       </a:pPr>
+                      <a:r>
+                        <a:rPr lang="en-US" sz="900" dirty="0">
+                          <a:solidFill>
+                            <a:srgbClr val="52514E"/>
+                          </a:solidFill>
+                          <a:latin typeface="Arial" pitchFamily="34" charset="0"/>
+                          <a:ea typeface="Arial" pitchFamily="34" charset="-122"/>
+                          <a:cs typeface="Arial" pitchFamily="34" charset="-120"/>
+                        </a:rPr>
+                        <a:t>Sector</a:t>
+                      </a:r>
+                      <a:endParaRPr lang="en-US" sz="900" dirty="0">
+                        <a:latin typeface="Arial" charset="0"/>
+                        <a:ea typeface="Arial" charset="0"/>
+                        <a:cs typeface="Arial" charset="0"/>
+                      </a:endParaRPr>
+                    </a:p>
+                  </a:txBody>
+                  <a:tcPr marL="27432" marR="27432" marT="18288" marB="18288" anchor="ctr">
+                    <a:lnL w="0" cap="flat" cmpd="sng" algn="ctr">
+                      <a:noFill/>
+                    </a:lnL>
+                    <a:lnR w="0" cap="flat" cmpd="sng" algn="ctr">
+                      <a:noFill/>
+                    </a:lnR>
+                    <a:lnT w="0" cap="flat" cmpd="sng" algn="ctr">
+                      <a:noFill/>
+                    </a:lnT>
+                    <a:lnB w="9525" cap="flat" cmpd="sng" algn="ctr">
+                      <a:solidFill>
+                        <a:srgbClr val="E1E0D9"/>
+                      </a:solidFill>
+                      <a:prstDash val="solid"/>
+                      <a:round/>
+                      <a:headEnd type="none" w="med" len="med"/>
+                      <a:tailEnd type="none" w="med" len="med"/>
+                    </a:lnB>
+                  </a:tcPr>
+                </a:tc>
+                <a:tc>
+                  <a:txBody>
+                    <a:bodyPr/>
+                    <a:lstStyle/>
+                    <a:p>
+                      <a:pPr indent="0" marL="0">
+                        <a:buNone/>
+                      </a:pPr>
                       <a:endParaRPr lang="en-US" sz="950" dirty="0">
                         <a:latin typeface="Arial" charset="0"/>
                         <a:ea typeface="Arial" charset="0"/>
@@ -4280,6 +4845,53 @@
                       <a:pPr indent="0" marL="0">
                         <a:buNone/>
                       </a:pPr>
+                      <a:r>
+                        <a:rPr lang="en-US" sz="900" dirty="0">
+                          <a:solidFill>
+                            <a:srgbClr val="52514E"/>
+                          </a:solidFill>
+                          <a:latin typeface="Arial" pitchFamily="34" charset="0"/>
+                          <a:ea typeface="Arial" pitchFamily="34" charset="-122"/>
+                          <a:cs typeface="Arial" pitchFamily="34" charset="-120"/>
+                        </a:rPr>
+                        <a:t>Sector</a:t>
+                      </a:r>
+                      <a:endParaRPr lang="en-US" sz="900" dirty="0">
+                        <a:latin typeface="Arial" charset="0"/>
+                        <a:ea typeface="Arial" charset="0"/>
+                        <a:cs typeface="Arial" charset="0"/>
+                      </a:endParaRPr>
+                    </a:p>
+                  </a:txBody>
+                  <a:tcPr marL="27432" marR="27432" marT="18288" marB="18288" anchor="ctr">
+                    <a:lnL w="0" cap="flat" cmpd="sng" algn="ctr">
+                      <a:noFill/>
+                    </a:lnL>
+                    <a:lnR w="0" cap="flat" cmpd="sng" algn="ctr">
+                      <a:noFill/>
+                    </a:lnR>
+                    <a:lnT w="0" cap="flat" cmpd="sng" algn="ctr">
+                      <a:noFill/>
+                    </a:lnT>
+                    <a:lnB w="9525" cap="flat" cmpd="sng" algn="ctr">
+                      <a:solidFill>
+                        <a:srgbClr val="E1E0D9"/>
+                      </a:solidFill>
+                      <a:prstDash val="solid"/>
+                      <a:round/>
+                      <a:headEnd type="none" w="med" len="med"/>
+                      <a:tailEnd type="none" w="med" len="med"/>
+                    </a:lnB>
+                  </a:tcPr>
+                </a:tc>
+                <a:tc>
+                  <a:txBody>
+                    <a:bodyPr/>
+                    <a:lstStyle/>
+                    <a:p>
+                      <a:pPr indent="0" marL="0">
+                        <a:buNone/>
+                      </a:pPr>
                       <a:endParaRPr lang="en-US" sz="950" dirty="0">
                         <a:latin typeface="Arial" charset="0"/>
                         <a:ea typeface="Arial" charset="0"/>
@@ -4459,6 +5071,53 @@
                       <a:pPr indent="0" marL="0">
                         <a:buNone/>
                       </a:pPr>
+                      <a:r>
+                        <a:rPr lang="en-US" sz="900" dirty="0">
+                          <a:solidFill>
+                            <a:srgbClr val="52514E"/>
+                          </a:solidFill>
+                          <a:latin typeface="Arial" pitchFamily="34" charset="0"/>
+                          <a:ea typeface="Arial" pitchFamily="34" charset="-122"/>
+                          <a:cs typeface="Arial" pitchFamily="34" charset="-120"/>
+                        </a:rPr>
+                        <a:t>Sector</a:t>
+                      </a:r>
+                      <a:endParaRPr lang="en-US" sz="900" dirty="0">
+                        <a:latin typeface="Arial" charset="0"/>
+                        <a:ea typeface="Arial" charset="0"/>
+                        <a:cs typeface="Arial" charset="0"/>
+                      </a:endParaRPr>
+                    </a:p>
+                  </a:txBody>
+                  <a:tcPr marL="27432" marR="27432" marT="18288" marB="18288" anchor="ctr">
+                    <a:lnL w="0" cap="flat" cmpd="sng" algn="ctr">
+                      <a:noFill/>
+                    </a:lnL>
+                    <a:lnR w="0" cap="flat" cmpd="sng" algn="ctr">
+                      <a:noFill/>
+                    </a:lnR>
+                    <a:lnT w="0" cap="flat" cmpd="sng" algn="ctr">
+                      <a:noFill/>
+                    </a:lnT>
+                    <a:lnB w="9525" cap="flat" cmpd="sng" algn="ctr">
+                      <a:solidFill>
+                        <a:srgbClr val="E1E0D9"/>
+                      </a:solidFill>
+                      <a:prstDash val="solid"/>
+                      <a:round/>
+                      <a:headEnd type="none" w="med" len="med"/>
+                      <a:tailEnd type="none" w="med" len="med"/>
+                    </a:lnB>
+                  </a:tcPr>
+                </a:tc>
+                <a:tc>
+                  <a:txBody>
+                    <a:bodyPr/>
+                    <a:lstStyle/>
+                    <a:p>
+                      <a:pPr indent="0" marL="0">
+                        <a:buNone/>
+                      </a:pPr>
                       <a:endParaRPr lang="en-US" sz="950" dirty="0">
                         <a:latin typeface="Arial" charset="0"/>
                         <a:ea typeface="Arial" charset="0"/>
@@ -4594,8 +5253,8 @@
         </p:nvSpPr>
         <p:spPr>
           <a:xfrm>
-            <a:off x="2286000" y="2887218"/>
-            <a:ext cx="932688" cy="219456"/>
+            <a:off x="2624328" y="2887218"/>
+            <a:ext cx="877824" cy="219456"/>
           </a:xfrm>
           <a:prstGeom prst="roundRect">
             <a:avLst>
@@ -4616,8 +5275,8 @@
         </p:nvSpPr>
         <p:spPr>
           <a:xfrm>
-            <a:off x="2286000" y="2887218"/>
-            <a:ext cx="932688" cy="219456"/>
+            <a:off x="2624328" y="2887218"/>
+            <a:ext cx="877824" cy="219456"/>
           </a:xfrm>
           <a:prstGeom prst="rect">
             <a:avLst/>
@@ -4669,8 +5328,8 @@
         </p:nvSpPr>
         <p:spPr>
           <a:xfrm>
-            <a:off x="2286000" y="3230118"/>
-            <a:ext cx="932688" cy="219456"/>
+            <a:off x="2624328" y="3230118"/>
+            <a:ext cx="877824" cy="219456"/>
           </a:xfrm>
           <a:prstGeom prst="roundRect">
             <a:avLst>
@@ -4691,8 +5350,8 @@
         </p:nvSpPr>
         <p:spPr>
           <a:xfrm>
-            <a:off x="2286000" y="3230118"/>
-            <a:ext cx="932688" cy="219456"/>
+            <a:off x="2624328" y="3230118"/>
+            <a:ext cx="877824" cy="219456"/>
           </a:xfrm>
           <a:prstGeom prst="rect">
             <a:avLst/>
@@ -4744,8 +5403,8 @@
         </p:nvSpPr>
         <p:spPr>
           <a:xfrm>
-            <a:off x="2286000" y="3573018"/>
-            <a:ext cx="932688" cy="219456"/>
+            <a:off x="2624328" y="3573018"/>
+            <a:ext cx="877824" cy="219456"/>
           </a:xfrm>
           <a:prstGeom prst="roundRect">
             <a:avLst>
@@ -4766,8 +5425,8 @@
         </p:nvSpPr>
         <p:spPr>
           <a:xfrm>
-            <a:off x="2286000" y="3573018"/>
-            <a:ext cx="932688" cy="219456"/>
+            <a:off x="2624328" y="3573018"/>
+            <a:ext cx="877824" cy="219456"/>
           </a:xfrm>
           <a:prstGeom prst="rect">
             <a:avLst/>
@@ -4819,8 +5478,8 @@
         </p:nvSpPr>
         <p:spPr>
           <a:xfrm>
-            <a:off x="2286000" y="3915918"/>
-            <a:ext cx="932688" cy="219456"/>
+            <a:off x="2624328" y="3915918"/>
+            <a:ext cx="877824" cy="219456"/>
           </a:xfrm>
           <a:prstGeom prst="roundRect">
             <a:avLst>
@@ -4841,8 +5500,8 @@
         </p:nvSpPr>
         <p:spPr>
           <a:xfrm>
-            <a:off x="2286000" y="3915918"/>
-            <a:ext cx="932688" cy="219456"/>
+            <a:off x="2624328" y="3915918"/>
+            <a:ext cx="877824" cy="219456"/>
           </a:xfrm>
           <a:prstGeom prst="rect">
             <a:avLst/>
@@ -4894,8 +5553,8 @@
         </p:nvSpPr>
         <p:spPr>
           <a:xfrm>
-            <a:off x="2286000" y="4258818"/>
-            <a:ext cx="932688" cy="219456"/>
+            <a:off x="2624328" y="4258818"/>
+            <a:ext cx="877824" cy="219456"/>
           </a:xfrm>
           <a:prstGeom prst="roundRect">
             <a:avLst>
@@ -4916,8 +5575,8 @@
         </p:nvSpPr>
         <p:spPr>
           <a:xfrm>
-            <a:off x="2286000" y="4258818"/>
-            <a:ext cx="932688" cy="219456"/>
+            <a:off x="2624328" y="4258818"/>
+            <a:ext cx="877824" cy="219456"/>
           </a:xfrm>
           <a:prstGeom prst="rect">
             <a:avLst/>
@@ -4969,8 +5628,8 @@
         </p:nvSpPr>
         <p:spPr>
           <a:xfrm>
-            <a:off x="2286000" y="4601718"/>
-            <a:ext cx="932688" cy="219456"/>
+            <a:off x="2624328" y="4601718"/>
+            <a:ext cx="877824" cy="219456"/>
           </a:xfrm>
           <a:prstGeom prst="roundRect">
             <a:avLst>
@@ -4991,8 +5650,8 @@
         </p:nvSpPr>
         <p:spPr>
           <a:xfrm>
-            <a:off x="2286000" y="4601718"/>
-            <a:ext cx="932688" cy="219456"/>
+            <a:off x="2624328" y="4601718"/>
+            <a:ext cx="877824" cy="219456"/>
           </a:xfrm>
           <a:prstGeom prst="rect">
             <a:avLst/>
@@ -5044,8 +5703,8 @@
         </p:nvSpPr>
         <p:spPr>
           <a:xfrm>
-            <a:off x="2286000" y="4944618"/>
-            <a:ext cx="1060704" cy="219456"/>
+            <a:off x="2624328" y="4944618"/>
+            <a:ext cx="987552" cy="219456"/>
           </a:xfrm>
           <a:prstGeom prst="roundRect">
             <a:avLst>
@@ -5066,8 +5725,8 @@
         </p:nvSpPr>
         <p:spPr>
           <a:xfrm>
-            <a:off x="2286000" y="4944618"/>
-            <a:ext cx="1060704" cy="219456"/>
+            <a:off x="2624328" y="4944618"/>
+            <a:ext cx="987552" cy="219456"/>
           </a:xfrm>
           <a:prstGeom prst="rect">
             <a:avLst/>
@@ -5119,8 +5778,8 @@
         </p:nvSpPr>
         <p:spPr>
           <a:xfrm>
-            <a:off x="2286000" y="5287518"/>
-            <a:ext cx="1060704" cy="219456"/>
+            <a:off x="2624328" y="5287518"/>
+            <a:ext cx="987552" cy="219456"/>
           </a:xfrm>
           <a:prstGeom prst="roundRect">
             <a:avLst>
@@ -5141,8 +5800,8 @@
         </p:nvSpPr>
         <p:spPr>
           <a:xfrm>
-            <a:off x="2286000" y="5287518"/>
-            <a:ext cx="1060704" cy="219456"/>
+            <a:off x="2624328" y="5287518"/>
+            <a:ext cx="987552" cy="219456"/>
           </a:xfrm>
           <a:prstGeom prst="rect">
             <a:avLst/>
@@ -5194,8 +5853,8 @@
         </p:nvSpPr>
         <p:spPr>
           <a:xfrm>
-            <a:off x="2286000" y="5630418"/>
-            <a:ext cx="1060704" cy="219456"/>
+            <a:off x="2624328" y="5630418"/>
+            <a:ext cx="987552" cy="219456"/>
           </a:xfrm>
           <a:prstGeom prst="roundRect">
             <a:avLst>
@@ -5216,8 +5875,8 @@
         </p:nvSpPr>
         <p:spPr>
           <a:xfrm>
-            <a:off x="2286000" y="5630418"/>
-            <a:ext cx="1060704" cy="219456"/>
+            <a:off x="2624328" y="5630418"/>
+            <a:ext cx="987552" cy="219456"/>
           </a:xfrm>
           <a:prstGeom prst="rect">
             <a:avLst/>
@@ -5269,8 +5928,8 @@
         </p:nvSpPr>
         <p:spPr>
           <a:xfrm>
-            <a:off x="2286000" y="5973318"/>
-            <a:ext cx="731520" cy="219456"/>
+            <a:off x="2624328" y="5973318"/>
+            <a:ext cx="694944" cy="219456"/>
           </a:xfrm>
           <a:prstGeom prst="roundRect">
             <a:avLst>
@@ -5291,8 +5950,8 @@
         </p:nvSpPr>
         <p:spPr>
           <a:xfrm>
-            <a:off x="2286000" y="5973318"/>
-            <a:ext cx="731520" cy="219456"/>
+            <a:off x="2624328" y="5973318"/>
+            <a:ext cx="694944" cy="219456"/>
           </a:xfrm>
           <a:prstGeom prst="rect">
             <a:avLst/>
@@ -5344,8 +6003,8 @@
         </p:nvSpPr>
         <p:spPr>
           <a:xfrm>
-            <a:off x="2286000" y="6316218"/>
-            <a:ext cx="731520" cy="219456"/>
+            <a:off x="2624328" y="6316218"/>
+            <a:ext cx="694944" cy="219456"/>
           </a:xfrm>
           <a:prstGeom prst="roundRect">
             <a:avLst>
@@ -5366,8 +6025,8 @@
         </p:nvSpPr>
         <p:spPr>
           <a:xfrm>
-            <a:off x="2286000" y="6316218"/>
-            <a:ext cx="731520" cy="219456"/>
+            <a:off x="2624328" y="6316218"/>
+            <a:ext cx="694944" cy="219456"/>
           </a:xfrm>
           <a:prstGeom prst="rect">
             <a:avLst/>
@@ -5419,8 +6078,8 @@
         </p:nvSpPr>
         <p:spPr>
           <a:xfrm>
-            <a:off x="2286000" y="6659118"/>
-            <a:ext cx="731520" cy="219456"/>
+            <a:off x="2624328" y="6659118"/>
+            <a:ext cx="694944" cy="219456"/>
           </a:xfrm>
           <a:prstGeom prst="roundRect">
             <a:avLst>
@@ -5441,8 +6100,8 @@
         </p:nvSpPr>
         <p:spPr>
           <a:xfrm>
-            <a:off x="2286000" y="6659118"/>
-            <a:ext cx="731520" cy="219456"/>
+            <a:off x="2624328" y="6659118"/>
+            <a:ext cx="694944" cy="219456"/>
           </a:xfrm>
           <a:prstGeom prst="rect">
             <a:avLst/>
@@ -5494,8 +6153,8 @@
         </p:nvSpPr>
         <p:spPr>
           <a:xfrm>
-            <a:off x="2286000" y="7002018"/>
-            <a:ext cx="731520" cy="219456"/>
+            <a:off x="2624328" y="7002018"/>
+            <a:ext cx="694944" cy="219456"/>
           </a:xfrm>
           <a:prstGeom prst="roundRect">
             <a:avLst>
@@ -5516,8 +6175,8 @@
         </p:nvSpPr>
         <p:spPr>
           <a:xfrm>
-            <a:off x="2286000" y="7002018"/>
-            <a:ext cx="731520" cy="219456"/>
+            <a:off x="2624328" y="7002018"/>
+            <a:ext cx="694944" cy="219456"/>
           </a:xfrm>
           <a:prstGeom prst="rect">
             <a:avLst/>
@@ -5569,7 +6228,7 @@
         </p:nvSpPr>
         <p:spPr>
           <a:xfrm>
-            <a:off x="6126480" y="2162556"/>
+            <a:off x="5742432" y="2162556"/>
             <a:ext cx="274320" cy="187452"/>
           </a:xfrm>
           <a:prstGeom prst="roundRect">
@@ -5596,7 +6255,7 @@
         </p:nvSpPr>
         <p:spPr>
           <a:xfrm>
-            <a:off x="6211153" y="2203795"/>
+            <a:off x="5827105" y="2203795"/>
             <a:ext cx="104973" cy="104973"/>
           </a:xfrm>
           <a:prstGeom prst="ellipse">
@@ -5616,7 +6275,7 @@
         </p:nvSpPr>
         <p:spPr>
           <a:xfrm>
-            <a:off x="6211153" y="2203795"/>
+            <a:off x="5827105" y="2203795"/>
             <a:ext cx="104973" cy="104973"/>
           </a:xfrm>
           <a:prstGeom prst="pie">
@@ -5639,7 +6298,7 @@
         </p:nvSpPr>
         <p:spPr>
           <a:xfrm>
-            <a:off x="6473952" y="2121408"/>
+            <a:off x="6089904" y="2121408"/>
             <a:ext cx="1463040" cy="274320"/>
           </a:xfrm>
           <a:prstGeom prst="rect">
@@ -5731,8 +6390,8 @@
         </p:nvSpPr>
         <p:spPr>
           <a:xfrm>
-            <a:off x="6126480" y="2459736"/>
-            <a:ext cx="3547872" cy="25603"/>
+            <a:off x="5742432" y="2459736"/>
+            <a:ext cx="3931920" cy="25603"/>
           </a:xfrm>
           <a:prstGeom prst="rect">
             <a:avLst/>
@@ -5758,18 +6417,19 @@
           </p:nvPr>
         </p:nvGraphicFramePr>
         <p:xfrm>
-          <a:off x="6126480" y="2569464"/>
-          <a:ext cx="3547872" cy="914400"/>
+          <a:off x="5742432" y="2569464"/>
+          <a:ext cx="3931920" cy="914400"/>
         </p:xfrm>
         <a:graphic>
           <a:graphicData uri="http://schemas.openxmlformats.org/drawingml/2006/table">
             <a:tbl>
               <a:tblPr/>
               <a:tblGrid>
-                <a:gridCol w="932688"/>
-                <a:gridCol w="1133856"/>
-                <a:gridCol w="640080"/>
-                <a:gridCol w="841248"/>
+                <a:gridCol w="859536"/>
+                <a:gridCol w="585216"/>
+                <a:gridCol w="1060704"/>
+                <a:gridCol w="621792"/>
+                <a:gridCol w="804672"/>
               </a:tblGrid>
               <a:tr h="256032">
                 <a:tc>
@@ -5836,6 +6496,53 @@
                           <a:ea typeface="Arial" pitchFamily="34" charset="-122"/>
                           <a:cs typeface="Arial" pitchFamily="34" charset="-120"/>
                         </a:rPr>
+                        <a:t>SECTOR</a:t>
+                      </a:r>
+                      <a:endParaRPr lang="en-US" sz="750" dirty="0">
+                        <a:latin typeface="Arial" charset="0"/>
+                        <a:ea typeface="Arial" charset="0"/>
+                        <a:cs typeface="Arial" charset="0"/>
+                      </a:endParaRPr>
+                    </a:p>
+                  </a:txBody>
+                  <a:tcPr marL="27432" marR="27432" marT="18288" marB="18288" anchor="ctr">
+                    <a:lnL w="0" cap="flat" cmpd="sng" algn="ctr">
+                      <a:noFill/>
+                    </a:lnL>
+                    <a:lnR w="0" cap="flat" cmpd="sng" algn="ctr">
+                      <a:noFill/>
+                    </a:lnR>
+                    <a:lnT w="0" cap="flat" cmpd="sng" algn="ctr">
+                      <a:noFill/>
+                    </a:lnT>
+                    <a:lnB w="15875" cap="flat" cmpd="sng" algn="ctr">
+                      <a:solidFill>
+                        <a:srgbClr val="E1E0D9"/>
+                      </a:solidFill>
+                      <a:prstDash val="solid"/>
+                      <a:round/>
+                      <a:headEnd type="none" w="med" len="med"/>
+                      <a:tailEnd type="none" w="med" len="med"/>
+                    </a:lnB>
+                  </a:tcPr>
+                </a:tc>
+                <a:tc>
+                  <a:txBody>
+                    <a:bodyPr/>
+                    <a:lstStyle/>
+                    <a:p>
+                      <a:pPr indent="0" marL="0">
+                        <a:buNone/>
+                      </a:pPr>
+                      <a:r>
+                        <a:rPr lang="en-US" sz="750" b="1" dirty="0">
+                          <a:solidFill>
+                            <a:srgbClr val="898781"/>
+                          </a:solidFill>
+                          <a:latin typeface="Arial" pitchFamily="34" charset="0"/>
+                          <a:ea typeface="Arial" pitchFamily="34" charset="-122"/>
+                          <a:cs typeface="Arial" pitchFamily="34" charset="-120"/>
+                        </a:rPr>
                         <a:t>STAGE</a:t>
                       </a:r>
                       <a:endParaRPr lang="en-US" sz="750" dirty="0">
@@ -5892,7 +6599,7 @@
                       </a:endParaRPr>
                     </a:p>
                   </a:txBody>
-                  <a:tcPr marL="27432" marR="91440" marT="18288" marB="18288" anchor="ctr">
+                  <a:tcPr marL="27432" marR="73152" marT="18288" marB="18288" anchor="ctr">
                     <a:lnL w="0" cap="flat" cmpd="sng" algn="ctr">
                       <a:noFill/>
                     </a:lnL>
@@ -6017,6 +6724,53 @@
                       <a:pPr indent="0" marL="0">
                         <a:buNone/>
                       </a:pPr>
+                      <a:r>
+                        <a:rPr lang="en-US" sz="900" dirty="0">
+                          <a:solidFill>
+                            <a:srgbClr val="52514E"/>
+                          </a:solidFill>
+                          <a:latin typeface="Arial" pitchFamily="34" charset="0"/>
+                          <a:ea typeface="Arial" pitchFamily="34" charset="-122"/>
+                          <a:cs typeface="Arial" pitchFamily="34" charset="-120"/>
+                        </a:rPr>
+                        <a:t>Sector</a:t>
+                      </a:r>
+                      <a:endParaRPr lang="en-US" sz="900" dirty="0">
+                        <a:latin typeface="Arial" charset="0"/>
+                        <a:ea typeface="Arial" charset="0"/>
+                        <a:cs typeface="Arial" charset="0"/>
+                      </a:endParaRPr>
+                    </a:p>
+                  </a:txBody>
+                  <a:tcPr marL="27432" marR="27432" marT="18288" marB="18288" anchor="ctr">
+                    <a:lnL w="0" cap="flat" cmpd="sng" algn="ctr">
+                      <a:noFill/>
+                    </a:lnL>
+                    <a:lnR w="0" cap="flat" cmpd="sng" algn="ctr">
+                      <a:noFill/>
+                    </a:lnR>
+                    <a:lnT w="0" cap="flat" cmpd="sng" algn="ctr">
+                      <a:noFill/>
+                    </a:lnT>
+                    <a:lnB w="9525" cap="flat" cmpd="sng" algn="ctr">
+                      <a:solidFill>
+                        <a:srgbClr val="E1E0D9"/>
+                      </a:solidFill>
+                      <a:prstDash val="solid"/>
+                      <a:round/>
+                      <a:headEnd type="none" w="med" len="med"/>
+                      <a:tailEnd type="none" w="med" len="med"/>
+                    </a:lnB>
+                  </a:tcPr>
+                </a:tc>
+                <a:tc>
+                  <a:txBody>
+                    <a:bodyPr/>
+                    <a:lstStyle/>
+                    <a:p>
+                      <a:pPr indent="0" marL="0">
+                        <a:buNone/>
+                      </a:pPr>
                       <a:endParaRPr lang="en-US" sz="950" dirty="0">
                         <a:latin typeface="Arial" charset="0"/>
                         <a:ea typeface="Arial" charset="0"/>
@@ -6196,6 +6950,53 @@
                       <a:pPr indent="0" marL="0">
                         <a:buNone/>
                       </a:pPr>
+                      <a:r>
+                        <a:rPr lang="en-US" sz="900" dirty="0">
+                          <a:solidFill>
+                            <a:srgbClr val="52514E"/>
+                          </a:solidFill>
+                          <a:latin typeface="Arial" pitchFamily="34" charset="0"/>
+                          <a:ea typeface="Arial" pitchFamily="34" charset="-122"/>
+                          <a:cs typeface="Arial" pitchFamily="34" charset="-120"/>
+                        </a:rPr>
+                        <a:t>Sector</a:t>
+                      </a:r>
+                      <a:endParaRPr lang="en-US" sz="900" dirty="0">
+                        <a:latin typeface="Arial" charset="0"/>
+                        <a:ea typeface="Arial" charset="0"/>
+                        <a:cs typeface="Arial" charset="0"/>
+                      </a:endParaRPr>
+                    </a:p>
+                  </a:txBody>
+                  <a:tcPr marL="27432" marR="27432" marT="18288" marB="18288" anchor="ctr">
+                    <a:lnL w="0" cap="flat" cmpd="sng" algn="ctr">
+                      <a:noFill/>
+                    </a:lnL>
+                    <a:lnR w="0" cap="flat" cmpd="sng" algn="ctr">
+                      <a:noFill/>
+                    </a:lnR>
+                    <a:lnT w="0" cap="flat" cmpd="sng" algn="ctr">
+                      <a:noFill/>
+                    </a:lnT>
+                    <a:lnB w="9525" cap="flat" cmpd="sng" algn="ctr">
+                      <a:solidFill>
+                        <a:srgbClr val="E1E0D9"/>
+                      </a:solidFill>
+                      <a:prstDash val="solid"/>
+                      <a:round/>
+                      <a:headEnd type="none" w="med" len="med"/>
+                      <a:tailEnd type="none" w="med" len="med"/>
+                    </a:lnB>
+                  </a:tcPr>
+                </a:tc>
+                <a:tc>
+                  <a:txBody>
+                    <a:bodyPr/>
+                    <a:lstStyle/>
+                    <a:p>
+                      <a:pPr indent="0" marL="0">
+                        <a:buNone/>
+                      </a:pPr>
                       <a:endParaRPr lang="en-US" sz="950" dirty="0">
                         <a:latin typeface="Arial" charset="0"/>
                         <a:ea typeface="Arial" charset="0"/>
@@ -6375,6 +7176,53 @@
                       <a:pPr indent="0" marL="0">
                         <a:buNone/>
                       </a:pPr>
+                      <a:r>
+                        <a:rPr lang="en-US" sz="900" dirty="0">
+                          <a:solidFill>
+                            <a:srgbClr val="52514E"/>
+                          </a:solidFill>
+                          <a:latin typeface="Arial" pitchFamily="34" charset="0"/>
+                          <a:ea typeface="Arial" pitchFamily="34" charset="-122"/>
+                          <a:cs typeface="Arial" pitchFamily="34" charset="-120"/>
+                        </a:rPr>
+                        <a:t>Sector</a:t>
+                      </a:r>
+                      <a:endParaRPr lang="en-US" sz="900" dirty="0">
+                        <a:latin typeface="Arial" charset="0"/>
+                        <a:ea typeface="Arial" charset="0"/>
+                        <a:cs typeface="Arial" charset="0"/>
+                      </a:endParaRPr>
+                    </a:p>
+                  </a:txBody>
+                  <a:tcPr marL="27432" marR="27432" marT="18288" marB="18288" anchor="ctr">
+                    <a:lnL w="0" cap="flat" cmpd="sng" algn="ctr">
+                      <a:noFill/>
+                    </a:lnL>
+                    <a:lnR w="0" cap="flat" cmpd="sng" algn="ctr">
+                      <a:noFill/>
+                    </a:lnR>
+                    <a:lnT w="0" cap="flat" cmpd="sng" algn="ctr">
+                      <a:noFill/>
+                    </a:lnT>
+                    <a:lnB w="9525" cap="flat" cmpd="sng" algn="ctr">
+                      <a:solidFill>
+                        <a:srgbClr val="E1E0D9"/>
+                      </a:solidFill>
+                      <a:prstDash val="solid"/>
+                      <a:round/>
+                      <a:headEnd type="none" w="med" len="med"/>
+                      <a:tailEnd type="none" w="med" len="med"/>
+                    </a:lnB>
+                  </a:tcPr>
+                </a:tc>
+                <a:tc>
+                  <a:txBody>
+                    <a:bodyPr/>
+                    <a:lstStyle/>
+                    <a:p>
+                      <a:pPr indent="0" marL="0">
+                        <a:buNone/>
+                      </a:pPr>
                       <a:endParaRPr lang="en-US" sz="950" dirty="0">
                         <a:latin typeface="Arial" charset="0"/>
                         <a:ea typeface="Arial" charset="0"/>
@@ -6554,6 +7402,53 @@
                       <a:pPr indent="0" marL="0">
                         <a:buNone/>
                       </a:pPr>
+                      <a:r>
+                        <a:rPr lang="en-US" sz="900" dirty="0">
+                          <a:solidFill>
+                            <a:srgbClr val="52514E"/>
+                          </a:solidFill>
+                          <a:latin typeface="Arial" pitchFamily="34" charset="0"/>
+                          <a:ea typeface="Arial" pitchFamily="34" charset="-122"/>
+                          <a:cs typeface="Arial" pitchFamily="34" charset="-120"/>
+                        </a:rPr>
+                        <a:t>Sector</a:t>
+                      </a:r>
+                      <a:endParaRPr lang="en-US" sz="900" dirty="0">
+                        <a:latin typeface="Arial" charset="0"/>
+                        <a:ea typeface="Arial" charset="0"/>
+                        <a:cs typeface="Arial" charset="0"/>
+                      </a:endParaRPr>
+                    </a:p>
+                  </a:txBody>
+                  <a:tcPr marL="27432" marR="27432" marT="18288" marB="18288" anchor="ctr">
+                    <a:lnL w="0" cap="flat" cmpd="sng" algn="ctr">
+                      <a:noFill/>
+                    </a:lnL>
+                    <a:lnR w="0" cap="flat" cmpd="sng" algn="ctr">
+                      <a:noFill/>
+                    </a:lnR>
+                    <a:lnT w="0" cap="flat" cmpd="sng" algn="ctr">
+                      <a:noFill/>
+                    </a:lnT>
+                    <a:lnB w="9525" cap="flat" cmpd="sng" algn="ctr">
+                      <a:solidFill>
+                        <a:srgbClr val="E1E0D9"/>
+                      </a:solidFill>
+                      <a:prstDash val="solid"/>
+                      <a:round/>
+                      <a:headEnd type="none" w="med" len="med"/>
+                      <a:tailEnd type="none" w="med" len="med"/>
+                    </a:lnB>
+                  </a:tcPr>
+                </a:tc>
+                <a:tc>
+                  <a:txBody>
+                    <a:bodyPr/>
+                    <a:lstStyle/>
+                    <a:p>
+                      <a:pPr indent="0" marL="0">
+                        <a:buNone/>
+                      </a:pPr>
                       <a:endParaRPr lang="en-US" sz="950" dirty="0">
                         <a:latin typeface="Arial" charset="0"/>
                         <a:ea typeface="Arial" charset="0"/>
@@ -6733,6 +7628,53 @@
                       <a:pPr indent="0" marL="0">
                         <a:buNone/>
                       </a:pPr>
+                      <a:r>
+                        <a:rPr lang="en-US" sz="900" dirty="0">
+                          <a:solidFill>
+                            <a:srgbClr val="52514E"/>
+                          </a:solidFill>
+                          <a:latin typeface="Arial" pitchFamily="34" charset="0"/>
+                          <a:ea typeface="Arial" pitchFamily="34" charset="-122"/>
+                          <a:cs typeface="Arial" pitchFamily="34" charset="-120"/>
+                        </a:rPr>
+                        <a:t>Sector</a:t>
+                      </a:r>
+                      <a:endParaRPr lang="en-US" sz="900" dirty="0">
+                        <a:latin typeface="Arial" charset="0"/>
+                        <a:ea typeface="Arial" charset="0"/>
+                        <a:cs typeface="Arial" charset="0"/>
+                      </a:endParaRPr>
+                    </a:p>
+                  </a:txBody>
+                  <a:tcPr marL="27432" marR="27432" marT="18288" marB="18288" anchor="ctr">
+                    <a:lnL w="0" cap="flat" cmpd="sng" algn="ctr">
+                      <a:noFill/>
+                    </a:lnL>
+                    <a:lnR w="0" cap="flat" cmpd="sng" algn="ctr">
+                      <a:noFill/>
+                    </a:lnR>
+                    <a:lnT w="0" cap="flat" cmpd="sng" algn="ctr">
+                      <a:noFill/>
+                    </a:lnT>
+                    <a:lnB w="9525" cap="flat" cmpd="sng" algn="ctr">
+                      <a:solidFill>
+                        <a:srgbClr val="E1E0D9"/>
+                      </a:solidFill>
+                      <a:prstDash val="solid"/>
+                      <a:round/>
+                      <a:headEnd type="none" w="med" len="med"/>
+                      <a:tailEnd type="none" w="med" len="med"/>
+                    </a:lnB>
+                  </a:tcPr>
+                </a:tc>
+                <a:tc>
+                  <a:txBody>
+                    <a:bodyPr/>
+                    <a:lstStyle/>
+                    <a:p>
+                      <a:pPr indent="0" marL="0">
+                        <a:buNone/>
+                      </a:pPr>
                       <a:endParaRPr lang="en-US" sz="950" dirty="0">
                         <a:latin typeface="Arial" charset="0"/>
                         <a:ea typeface="Arial" charset="0"/>
@@ -6912,6 +7854,53 @@
                       <a:pPr indent="0" marL="0">
                         <a:buNone/>
                       </a:pPr>
+                      <a:r>
+                        <a:rPr lang="en-US" sz="900" dirty="0">
+                          <a:solidFill>
+                            <a:srgbClr val="52514E"/>
+                          </a:solidFill>
+                          <a:latin typeface="Arial" pitchFamily="34" charset="0"/>
+                          <a:ea typeface="Arial" pitchFamily="34" charset="-122"/>
+                          <a:cs typeface="Arial" pitchFamily="34" charset="-120"/>
+                        </a:rPr>
+                        <a:t>Sector</a:t>
+                      </a:r>
+                      <a:endParaRPr lang="en-US" sz="900" dirty="0">
+                        <a:latin typeface="Arial" charset="0"/>
+                        <a:ea typeface="Arial" charset="0"/>
+                        <a:cs typeface="Arial" charset="0"/>
+                      </a:endParaRPr>
+                    </a:p>
+                  </a:txBody>
+                  <a:tcPr marL="27432" marR="27432" marT="18288" marB="18288" anchor="ctr">
+                    <a:lnL w="0" cap="flat" cmpd="sng" algn="ctr">
+                      <a:noFill/>
+                    </a:lnL>
+                    <a:lnR w="0" cap="flat" cmpd="sng" algn="ctr">
+                      <a:noFill/>
+                    </a:lnR>
+                    <a:lnT w="0" cap="flat" cmpd="sng" algn="ctr">
+                      <a:noFill/>
+                    </a:lnT>
+                    <a:lnB w="9525" cap="flat" cmpd="sng" algn="ctr">
+                      <a:solidFill>
+                        <a:srgbClr val="E1E0D9"/>
+                      </a:solidFill>
+                      <a:prstDash val="solid"/>
+                      <a:round/>
+                      <a:headEnd type="none" w="med" len="med"/>
+                      <a:tailEnd type="none" w="med" len="med"/>
+                    </a:lnB>
+                  </a:tcPr>
+                </a:tc>
+                <a:tc>
+                  <a:txBody>
+                    <a:bodyPr/>
+                    <a:lstStyle/>
+                    <a:p>
+                      <a:pPr indent="0" marL="0">
+                        <a:buNone/>
+                      </a:pPr>
                       <a:endParaRPr lang="en-US" sz="950" dirty="0">
                         <a:latin typeface="Arial" charset="0"/>
                         <a:ea typeface="Arial" charset="0"/>
@@ -7047,8 +8036,8 @@
         </p:nvSpPr>
         <p:spPr>
           <a:xfrm>
-            <a:off x="7114032" y="2887218"/>
-            <a:ext cx="1060704" cy="219456"/>
+            <a:off x="7232904" y="2887218"/>
+            <a:ext cx="987552" cy="219456"/>
           </a:xfrm>
           <a:prstGeom prst="roundRect">
             <a:avLst>
@@ -7069,8 +8058,8 @@
         </p:nvSpPr>
         <p:spPr>
           <a:xfrm>
-            <a:off x="7114032" y="2887218"/>
-            <a:ext cx="1060704" cy="219456"/>
+            <a:off x="7232904" y="2887218"/>
+            <a:ext cx="987552" cy="219456"/>
           </a:xfrm>
           <a:prstGeom prst="rect">
             <a:avLst/>
@@ -7122,8 +8111,8 @@
         </p:nvSpPr>
         <p:spPr>
           <a:xfrm>
-            <a:off x="7114032" y="3230118"/>
-            <a:ext cx="1060704" cy="219456"/>
+            <a:off x="7232904" y="3230118"/>
+            <a:ext cx="987552" cy="219456"/>
           </a:xfrm>
           <a:prstGeom prst="roundRect">
             <a:avLst>
@@ -7144,8 +8133,8 @@
         </p:nvSpPr>
         <p:spPr>
           <a:xfrm>
-            <a:off x="7114032" y="3230118"/>
-            <a:ext cx="1060704" cy="219456"/>
+            <a:off x="7232904" y="3230118"/>
+            <a:ext cx="987552" cy="219456"/>
           </a:xfrm>
           <a:prstGeom prst="rect">
             <a:avLst/>
@@ -7197,8 +8186,8 @@
         </p:nvSpPr>
         <p:spPr>
           <a:xfrm>
-            <a:off x="7114032" y="3573018"/>
-            <a:ext cx="1060704" cy="219456"/>
+            <a:off x="7232904" y="3573018"/>
+            <a:ext cx="987552" cy="219456"/>
           </a:xfrm>
           <a:prstGeom prst="roundRect">
             <a:avLst>
@@ -7219,8 +8208,8 @@
         </p:nvSpPr>
         <p:spPr>
           <a:xfrm>
-            <a:off x="7114032" y="3573018"/>
-            <a:ext cx="1060704" cy="219456"/>
+            <a:off x="7232904" y="3573018"/>
+            <a:ext cx="987552" cy="219456"/>
           </a:xfrm>
           <a:prstGeom prst="rect">
             <a:avLst/>
@@ -7272,8 +8261,8 @@
         </p:nvSpPr>
         <p:spPr>
           <a:xfrm>
-            <a:off x="7114032" y="3915918"/>
-            <a:ext cx="731520" cy="219456"/>
+            <a:off x="7232904" y="3915918"/>
+            <a:ext cx="694944" cy="219456"/>
           </a:xfrm>
           <a:prstGeom prst="roundRect">
             <a:avLst>
@@ -7294,8 +8283,8 @@
         </p:nvSpPr>
         <p:spPr>
           <a:xfrm>
-            <a:off x="7114032" y="3915918"/>
-            <a:ext cx="731520" cy="219456"/>
+            <a:off x="7232904" y="3915918"/>
+            <a:ext cx="694944" cy="219456"/>
           </a:xfrm>
           <a:prstGeom prst="rect">
             <a:avLst/>
@@ -7347,8 +8336,8 @@
         </p:nvSpPr>
         <p:spPr>
           <a:xfrm>
-            <a:off x="7114032" y="4258818"/>
-            <a:ext cx="731520" cy="219456"/>
+            <a:off x="7232904" y="4258818"/>
+            <a:ext cx="694944" cy="219456"/>
           </a:xfrm>
           <a:prstGeom prst="roundRect">
             <a:avLst>
@@ -7369,8 +8358,8 @@
         </p:nvSpPr>
         <p:spPr>
           <a:xfrm>
-            <a:off x="7114032" y="4258818"/>
-            <a:ext cx="731520" cy="219456"/>
+            <a:off x="7232904" y="4258818"/>
+            <a:ext cx="694944" cy="219456"/>
           </a:xfrm>
           <a:prstGeom prst="rect">
             <a:avLst/>
@@ -7422,8 +8411,8 @@
         </p:nvSpPr>
         <p:spPr>
           <a:xfrm>
-            <a:off x="7114032" y="4601718"/>
-            <a:ext cx="731520" cy="219456"/>
+            <a:off x="7232904" y="4601718"/>
+            <a:ext cx="694944" cy="219456"/>
           </a:xfrm>
           <a:prstGeom prst="roundRect">
             <a:avLst>
@@ -7444,8 +8433,8 @@
         </p:nvSpPr>
         <p:spPr>
           <a:xfrm>
-            <a:off x="7114032" y="4601718"/>
-            <a:ext cx="731520" cy="219456"/>
+            <a:off x="7232904" y="4601718"/>
+            <a:ext cx="694944" cy="219456"/>
           </a:xfrm>
           <a:prstGeom prst="rect">
             <a:avLst/>
@@ -7613,7 +8602,7 @@
         <p:spPr>
           <a:xfrm>
             <a:off x="10287000" y="2880360"/>
-            <a:ext cx="932688" cy="219456"/>
+            <a:ext cx="877824" cy="219456"/>
           </a:xfrm>
           <a:prstGeom prst="roundRect">
             <a:avLst>
@@ -7635,7 +8624,7 @@
         <p:spPr>
           <a:xfrm>
             <a:off x="10287000" y="2880360"/>
-            <a:ext cx="932688" cy="219456"/>
+            <a:ext cx="877824" cy="219456"/>
           </a:xfrm>
           <a:prstGeom prst="rect">
             <a:avLst/>
@@ -7688,7 +8677,7 @@
         <p:spPr>
           <a:xfrm>
             <a:off x="10287000" y="3200400"/>
-            <a:ext cx="1060704" cy="219456"/>
+            <a:ext cx="987552" cy="219456"/>
           </a:xfrm>
           <a:prstGeom prst="roundRect">
             <a:avLst>
@@ -7710,7 +8699,7 @@
         <p:spPr>
           <a:xfrm>
             <a:off x="10287000" y="3200400"/>
-            <a:ext cx="1060704" cy="219456"/>
+            <a:ext cx="987552" cy="219456"/>
           </a:xfrm>
           <a:prstGeom prst="rect">
             <a:avLst/>
@@ -7763,7 +8752,7 @@
         <p:spPr>
           <a:xfrm>
             <a:off x="10287000" y="3520440"/>
-            <a:ext cx="731520" cy="219456"/>
+            <a:ext cx="694944" cy="219456"/>
           </a:xfrm>
           <a:prstGeom prst="roundRect">
             <a:avLst>
@@ -7785,7 +8774,7 @@
         <p:spPr>
           <a:xfrm>
             <a:off x="10287000" y="3520440"/>
-            <a:ext cx="731520" cy="219456"/>
+            <a:ext cx="694944" cy="219456"/>
           </a:xfrm>
           <a:prstGeom prst="rect">
             <a:avLst/>

</xml_diff>

<commit_message>
Add Warrants % column and equalize Japan/Korea table widths
Both tables now share one column layout (Company, Sector, Stage, Deal
Size, Owner's Rep, Warrants %) at identical width.

Co-Authored-By: Claude Fable 5 <noreply@anthropic.com>
Claude-Session: https://claude.ai/code/session_01Egzj3n6LAZJYJNpNFgwsPm
</commit_message>
<xml_diff>
--- a/deal-status-onepager/US-Investment-Accelerator-Deal-Status.pptx
+++ b/deal-status-onepager/US-Investment-Accelerator-Deal-Status.pptx
@@ -503,7 +503,7 @@
             <a:r>
               <a:rPr lang="en-US" dirty="0"/>
               <a:t>FILL-IN GUIDE
-1. Type over every gray/placeholder value: Company 1-19, Sector, the $X.X B deal sizes (all in billions), First Last (owner's rep), the summary tiles, and the two '$XX.X B total' figures next to JAPAN and KOREA.
+1. Type over every gray/placeholder value: Company 1-19, Sector, the $X.X B deal sizes (all in billions), First Last (owner's rep), X.X% (warrants), the summary tiles, and the two '$XX.X B total' figures next to JAPAN and KOREA.
 2. Stage tags are already set to the plan: Japan = 6 Announced, 3 Consultation, 4 Active. Korea = 3 Consultation, 3 Active (none announced). To change one anyway, delete it and Ctrl/Cmd-drag a spare tag from the right of the page into place. The spares sit off the page and never print.
 3. Add/remove rows: click in a table, use Table Layout &gt; Insert/Delete Rows. If you change row counts, drag the tags to keep them aligned with their rows, and update the counts in the summary strip.
 4. Rows are grouped by stage: Announced first, then Consultation, then Active.
@@ -1972,7 +1972,7 @@
         </p:nvSpPr>
         <p:spPr>
           <a:xfrm>
-            <a:off x="2761488" y="2171700"/>
+            <a:off x="2148840" y="2171700"/>
             <a:ext cx="2743200" cy="201168"/>
           </a:xfrm>
           <a:prstGeom prst="rect">
@@ -2026,7 +2026,7 @@
         <p:spPr>
           <a:xfrm>
             <a:off x="384048" y="2459736"/>
-            <a:ext cx="5120640" cy="25603"/>
+            <a:ext cx="4507992" cy="25603"/>
           </a:xfrm>
           <a:prstGeom prst="rect">
             <a:avLst/>
@@ -2053,18 +2053,19 @@
         </p:nvGraphicFramePr>
         <p:xfrm>
           <a:off x="384048" y="2569464"/>
-          <a:ext cx="5120640" cy="914400"/>
+          <a:ext cx="4507992" cy="914400"/>
         </p:xfrm>
         <a:graphic>
           <a:graphicData uri="http://schemas.openxmlformats.org/drawingml/2006/table">
             <a:tbl>
               <a:tblPr/>
               <a:tblGrid>
-                <a:gridCol w="1298448"/>
-                <a:gridCol w="896112"/>
-                <a:gridCol w="1097280"/>
-                <a:gridCol w="731520"/>
-                <a:gridCol w="1097280"/>
+                <a:gridCol w="832104"/>
+                <a:gridCol w="566928"/>
+                <a:gridCol w="1042416"/>
+                <a:gridCol w="576072"/>
+                <a:gridCol w="749808"/>
+                <a:gridCol w="740664"/>
               </a:tblGrid>
               <a:tr h="256032">
                 <a:tc>
@@ -2076,7 +2077,7 @@
                         <a:buNone/>
                       </a:pPr>
                       <a:r>
-                        <a:rPr lang="en-US" sz="800" b="1" spc="50" kern="0" dirty="0">
+                        <a:rPr lang="en-US" sz="700" b="1" dirty="0">
                           <a:solidFill>
                             <a:srgbClr val="898781"/>
                           </a:solidFill>
@@ -2086,7 +2087,7 @@
                         </a:rPr>
                         <a:t>COMPANY</a:t>
                       </a:r>
-                      <a:endParaRPr lang="en-US" sz="800" dirty="0">
+                      <a:endParaRPr lang="en-US" sz="700" dirty="0">
                         <a:latin typeface="Arial" charset="0"/>
                         <a:ea typeface="Arial" charset="0"/>
                         <a:cs typeface="Arial" charset="0"/>
@@ -2123,7 +2124,7 @@
                         <a:buNone/>
                       </a:pPr>
                       <a:r>
-                        <a:rPr lang="en-US" sz="800" b="1" spc="50" kern="0" dirty="0">
+                        <a:rPr lang="en-US" sz="700" b="1" dirty="0">
                           <a:solidFill>
                             <a:srgbClr val="898781"/>
                           </a:solidFill>
@@ -2133,7 +2134,7 @@
                         </a:rPr>
                         <a:t>SECTOR</a:t>
                       </a:r>
-                      <a:endParaRPr lang="en-US" sz="800" dirty="0">
+                      <a:endParaRPr lang="en-US" sz="700" dirty="0">
                         <a:latin typeface="Arial" charset="0"/>
                         <a:ea typeface="Arial" charset="0"/>
                         <a:cs typeface="Arial" charset="0"/>
@@ -2170,7 +2171,7 @@
                         <a:buNone/>
                       </a:pPr>
                       <a:r>
-                        <a:rPr lang="en-US" sz="800" b="1" spc="50" kern="0" dirty="0">
+                        <a:rPr lang="en-US" sz="700" b="1" dirty="0">
                           <a:solidFill>
                             <a:srgbClr val="898781"/>
                           </a:solidFill>
@@ -2180,7 +2181,7 @@
                         </a:rPr>
                         <a:t>STAGE</a:t>
                       </a:r>
-                      <a:endParaRPr lang="en-US" sz="800" dirty="0">
+                      <a:endParaRPr lang="en-US" sz="700" dirty="0">
                         <a:latin typeface="Arial" charset="0"/>
                         <a:ea typeface="Arial" charset="0"/>
                         <a:cs typeface="Arial" charset="0"/>
@@ -2217,7 +2218,7 @@
                         <a:buNone/>
                       </a:pPr>
                       <a:r>
-                        <a:rPr lang="en-US" sz="800" b="1" spc="50" kern="0" dirty="0">
+                        <a:rPr lang="en-US" sz="700" b="1" dirty="0">
                           <a:solidFill>
                             <a:srgbClr val="898781"/>
                           </a:solidFill>
@@ -2227,7 +2228,7 @@
                         </a:rPr>
                         <a:t>DEAL SIZE</a:t>
                       </a:r>
-                      <a:endParaRPr lang="en-US" sz="800" dirty="0">
+                      <a:endParaRPr lang="en-US" sz="700" dirty="0">
                         <a:latin typeface="Arial" charset="0"/>
                         <a:ea typeface="Arial" charset="0"/>
                         <a:cs typeface="Arial" charset="0"/>
@@ -2264,7 +2265,7 @@
                         <a:buNone/>
                       </a:pPr>
                       <a:r>
-                        <a:rPr lang="en-US" sz="800" b="1" spc="50" kern="0" dirty="0">
+                        <a:rPr lang="en-US" sz="700" b="1" dirty="0">
                           <a:solidFill>
                             <a:srgbClr val="898781"/>
                           </a:solidFill>
@@ -2274,14 +2275,61 @@
                         </a:rPr>
                         <a:t>OWNER’S REP</a:t>
                       </a:r>
-                      <a:endParaRPr lang="en-US" sz="800" dirty="0">
-                        <a:latin typeface="Arial" charset="0"/>
-                        <a:ea typeface="Arial" charset="0"/>
-                        <a:cs typeface="Arial" charset="0"/>
-                      </a:endParaRPr>
-                    </a:p>
-                  </a:txBody>
-                  <a:tcPr marL="91440" marR="27432" marT="18288" marB="18288" anchor="ctr">
+                      <a:endParaRPr lang="en-US" sz="700" dirty="0">
+                        <a:latin typeface="Arial" charset="0"/>
+                        <a:ea typeface="Arial" charset="0"/>
+                        <a:cs typeface="Arial" charset="0"/>
+                      </a:endParaRPr>
+                    </a:p>
+                  </a:txBody>
+                  <a:tcPr marL="54864" marR="27432" marT="18288" marB="18288" anchor="ctr">
+                    <a:lnL w="0" cap="flat" cmpd="sng" algn="ctr">
+                      <a:noFill/>
+                    </a:lnL>
+                    <a:lnR w="0" cap="flat" cmpd="sng" algn="ctr">
+                      <a:noFill/>
+                    </a:lnR>
+                    <a:lnT w="0" cap="flat" cmpd="sng" algn="ctr">
+                      <a:noFill/>
+                    </a:lnT>
+                    <a:lnB w="15875" cap="flat" cmpd="sng" algn="ctr">
+                      <a:solidFill>
+                        <a:srgbClr val="E1E0D9"/>
+                      </a:solidFill>
+                      <a:prstDash val="solid"/>
+                      <a:round/>
+                      <a:headEnd type="none" w="med" len="med"/>
+                      <a:tailEnd type="none" w="med" len="med"/>
+                    </a:lnB>
+                  </a:tcPr>
+                </a:tc>
+                <a:tc>
+                  <a:txBody>
+                    <a:bodyPr/>
+                    <a:lstStyle/>
+                    <a:p>
+                      <a:pPr algn="r" indent="0" marL="0">
+                        <a:buNone/>
+                      </a:pPr>
+                      <a:r>
+                        <a:rPr lang="en-US" sz="700" b="1" dirty="0">
+                          <a:solidFill>
+                            <a:srgbClr val="898781"/>
+                          </a:solidFill>
+                          <a:latin typeface="Arial" pitchFamily="34" charset="0"/>
+                          <a:ea typeface="Arial" pitchFamily="34" charset="-122"/>
+                          <a:cs typeface="Arial" pitchFamily="34" charset="-120"/>
+                        </a:rPr>
+                        <a:t>WARRANTS %</a:t>
+                      </a:r>
+                      <a:endParaRPr lang="en-US" sz="700" dirty="0">
+                        <a:latin typeface="Arial" charset="0"/>
+                        <a:ea typeface="Arial" charset="0"/>
+                        <a:cs typeface="Arial" charset="0"/>
+                      </a:endParaRPr>
+                    </a:p>
+                  </a:txBody>
+                  <a:tcPr marL="27432" marR="73152" marT="18288" marB="18288" anchor="ctr">
                     <a:lnL w="0" cap="flat" cmpd="sng" algn="ctr">
                       <a:noFill/>
                     </a:lnL>
@@ -2507,7 +2555,54 @@
                       </a:endParaRPr>
                     </a:p>
                   </a:txBody>
-                  <a:tcPr marL="109728" marR="27432" marT="18288" marB="18288" anchor="ctr">
+                  <a:tcPr marL="54864" marR="27432" marT="18288" marB="18288" anchor="ctr">
+                    <a:lnL w="0" cap="flat" cmpd="sng" algn="ctr">
+                      <a:noFill/>
+                    </a:lnL>
+                    <a:lnR w="0" cap="flat" cmpd="sng" algn="ctr">
+                      <a:noFill/>
+                    </a:lnR>
+                    <a:lnT w="0" cap="flat" cmpd="sng" algn="ctr">
+                      <a:noFill/>
+                    </a:lnT>
+                    <a:lnB w="9525" cap="flat" cmpd="sng" algn="ctr">
+                      <a:solidFill>
+                        <a:srgbClr val="E1E0D9"/>
+                      </a:solidFill>
+                      <a:prstDash val="solid"/>
+                      <a:round/>
+                      <a:headEnd type="none" w="med" len="med"/>
+                      <a:tailEnd type="none" w="med" len="med"/>
+                    </a:lnB>
+                  </a:tcPr>
+                </a:tc>
+                <a:tc>
+                  <a:txBody>
+                    <a:bodyPr/>
+                    <a:lstStyle/>
+                    <a:p>
+                      <a:pPr algn="r" indent="0" marL="0">
+                        <a:buNone/>
+                      </a:pPr>
+                      <a:r>
+                        <a:rPr lang="en-US" sz="950" dirty="0">
+                          <a:solidFill>
+                            <a:srgbClr val="0B0B0B"/>
+                          </a:solidFill>
+                          <a:latin typeface="Arial" pitchFamily="34" charset="0"/>
+                          <a:ea typeface="Arial" pitchFamily="34" charset="-122"/>
+                          <a:cs typeface="Arial" pitchFamily="34" charset="-120"/>
+                        </a:rPr>
+                        <a:t>X.X%</a:t>
+                      </a:r>
+                      <a:endParaRPr lang="en-US" sz="950" dirty="0">
+                        <a:latin typeface="Arial" charset="0"/>
+                        <a:ea typeface="Arial" charset="0"/>
+                        <a:cs typeface="Arial" charset="0"/>
+                      </a:endParaRPr>
+                    </a:p>
+                  </a:txBody>
+                  <a:tcPr marL="27432" marR="91440" marT="18288" marB="18288" anchor="ctr">
                     <a:lnL w="0" cap="flat" cmpd="sng" algn="ctr">
                       <a:noFill/>
                     </a:lnL>
@@ -2733,7 +2828,54 @@
                       </a:endParaRPr>
                     </a:p>
                   </a:txBody>
-                  <a:tcPr marL="109728" marR="27432" marT="18288" marB="18288" anchor="ctr">
+                  <a:tcPr marL="54864" marR="27432" marT="18288" marB="18288" anchor="ctr">
+                    <a:lnL w="0" cap="flat" cmpd="sng" algn="ctr">
+                      <a:noFill/>
+                    </a:lnL>
+                    <a:lnR w="0" cap="flat" cmpd="sng" algn="ctr">
+                      <a:noFill/>
+                    </a:lnR>
+                    <a:lnT w="0" cap="flat" cmpd="sng" algn="ctr">
+                      <a:noFill/>
+                    </a:lnT>
+                    <a:lnB w="9525" cap="flat" cmpd="sng" algn="ctr">
+                      <a:solidFill>
+                        <a:srgbClr val="E1E0D9"/>
+                      </a:solidFill>
+                      <a:prstDash val="solid"/>
+                      <a:round/>
+                      <a:headEnd type="none" w="med" len="med"/>
+                      <a:tailEnd type="none" w="med" len="med"/>
+                    </a:lnB>
+                  </a:tcPr>
+                </a:tc>
+                <a:tc>
+                  <a:txBody>
+                    <a:bodyPr/>
+                    <a:lstStyle/>
+                    <a:p>
+                      <a:pPr algn="r" indent="0" marL="0">
+                        <a:buNone/>
+                      </a:pPr>
+                      <a:r>
+                        <a:rPr lang="en-US" sz="950" dirty="0">
+                          <a:solidFill>
+                            <a:srgbClr val="0B0B0B"/>
+                          </a:solidFill>
+                          <a:latin typeface="Arial" pitchFamily="34" charset="0"/>
+                          <a:ea typeface="Arial" pitchFamily="34" charset="-122"/>
+                          <a:cs typeface="Arial" pitchFamily="34" charset="-120"/>
+                        </a:rPr>
+                        <a:t>X.X%</a:t>
+                      </a:r>
+                      <a:endParaRPr lang="en-US" sz="950" dirty="0">
+                        <a:latin typeface="Arial" charset="0"/>
+                        <a:ea typeface="Arial" charset="0"/>
+                        <a:cs typeface="Arial" charset="0"/>
+                      </a:endParaRPr>
+                    </a:p>
+                  </a:txBody>
+                  <a:tcPr marL="27432" marR="91440" marT="18288" marB="18288" anchor="ctr">
                     <a:lnL w="0" cap="flat" cmpd="sng" algn="ctr">
                       <a:noFill/>
                     </a:lnL>
@@ -2959,7 +3101,54 @@
                       </a:endParaRPr>
                     </a:p>
                   </a:txBody>
-                  <a:tcPr marL="109728" marR="27432" marT="18288" marB="18288" anchor="ctr">
+                  <a:tcPr marL="54864" marR="27432" marT="18288" marB="18288" anchor="ctr">
+                    <a:lnL w="0" cap="flat" cmpd="sng" algn="ctr">
+                      <a:noFill/>
+                    </a:lnL>
+                    <a:lnR w="0" cap="flat" cmpd="sng" algn="ctr">
+                      <a:noFill/>
+                    </a:lnR>
+                    <a:lnT w="0" cap="flat" cmpd="sng" algn="ctr">
+                      <a:noFill/>
+                    </a:lnT>
+                    <a:lnB w="9525" cap="flat" cmpd="sng" algn="ctr">
+                      <a:solidFill>
+                        <a:srgbClr val="E1E0D9"/>
+                      </a:solidFill>
+                      <a:prstDash val="solid"/>
+                      <a:round/>
+                      <a:headEnd type="none" w="med" len="med"/>
+                      <a:tailEnd type="none" w="med" len="med"/>
+                    </a:lnB>
+                  </a:tcPr>
+                </a:tc>
+                <a:tc>
+                  <a:txBody>
+                    <a:bodyPr/>
+                    <a:lstStyle/>
+                    <a:p>
+                      <a:pPr algn="r" indent="0" marL="0">
+                        <a:buNone/>
+                      </a:pPr>
+                      <a:r>
+                        <a:rPr lang="en-US" sz="950" dirty="0">
+                          <a:solidFill>
+                            <a:srgbClr val="0B0B0B"/>
+                          </a:solidFill>
+                          <a:latin typeface="Arial" pitchFamily="34" charset="0"/>
+                          <a:ea typeface="Arial" pitchFamily="34" charset="-122"/>
+                          <a:cs typeface="Arial" pitchFamily="34" charset="-120"/>
+                        </a:rPr>
+                        <a:t>X.X%</a:t>
+                      </a:r>
+                      <a:endParaRPr lang="en-US" sz="950" dirty="0">
+                        <a:latin typeface="Arial" charset="0"/>
+                        <a:ea typeface="Arial" charset="0"/>
+                        <a:cs typeface="Arial" charset="0"/>
+                      </a:endParaRPr>
+                    </a:p>
+                  </a:txBody>
+                  <a:tcPr marL="27432" marR="91440" marT="18288" marB="18288" anchor="ctr">
                     <a:lnL w="0" cap="flat" cmpd="sng" algn="ctr">
                       <a:noFill/>
                     </a:lnL>
@@ -3185,7 +3374,54 @@
                       </a:endParaRPr>
                     </a:p>
                   </a:txBody>
-                  <a:tcPr marL="109728" marR="27432" marT="18288" marB="18288" anchor="ctr">
+                  <a:tcPr marL="54864" marR="27432" marT="18288" marB="18288" anchor="ctr">
+                    <a:lnL w="0" cap="flat" cmpd="sng" algn="ctr">
+                      <a:noFill/>
+                    </a:lnL>
+                    <a:lnR w="0" cap="flat" cmpd="sng" algn="ctr">
+                      <a:noFill/>
+                    </a:lnR>
+                    <a:lnT w="0" cap="flat" cmpd="sng" algn="ctr">
+                      <a:noFill/>
+                    </a:lnT>
+                    <a:lnB w="9525" cap="flat" cmpd="sng" algn="ctr">
+                      <a:solidFill>
+                        <a:srgbClr val="E1E0D9"/>
+                      </a:solidFill>
+                      <a:prstDash val="solid"/>
+                      <a:round/>
+                      <a:headEnd type="none" w="med" len="med"/>
+                      <a:tailEnd type="none" w="med" len="med"/>
+                    </a:lnB>
+                  </a:tcPr>
+                </a:tc>
+                <a:tc>
+                  <a:txBody>
+                    <a:bodyPr/>
+                    <a:lstStyle/>
+                    <a:p>
+                      <a:pPr algn="r" indent="0" marL="0">
+                        <a:buNone/>
+                      </a:pPr>
+                      <a:r>
+                        <a:rPr lang="en-US" sz="950" dirty="0">
+                          <a:solidFill>
+                            <a:srgbClr val="0B0B0B"/>
+                          </a:solidFill>
+                          <a:latin typeface="Arial" pitchFamily="34" charset="0"/>
+                          <a:ea typeface="Arial" pitchFamily="34" charset="-122"/>
+                          <a:cs typeface="Arial" pitchFamily="34" charset="-120"/>
+                        </a:rPr>
+                        <a:t>X.X%</a:t>
+                      </a:r>
+                      <a:endParaRPr lang="en-US" sz="950" dirty="0">
+                        <a:latin typeface="Arial" charset="0"/>
+                        <a:ea typeface="Arial" charset="0"/>
+                        <a:cs typeface="Arial" charset="0"/>
+                      </a:endParaRPr>
+                    </a:p>
+                  </a:txBody>
+                  <a:tcPr marL="27432" marR="91440" marT="18288" marB="18288" anchor="ctr">
                     <a:lnL w="0" cap="flat" cmpd="sng" algn="ctr">
                       <a:noFill/>
                     </a:lnL>
@@ -3411,7 +3647,54 @@
                       </a:endParaRPr>
                     </a:p>
                   </a:txBody>
-                  <a:tcPr marL="109728" marR="27432" marT="18288" marB="18288" anchor="ctr">
+                  <a:tcPr marL="54864" marR="27432" marT="18288" marB="18288" anchor="ctr">
+                    <a:lnL w="0" cap="flat" cmpd="sng" algn="ctr">
+                      <a:noFill/>
+                    </a:lnL>
+                    <a:lnR w="0" cap="flat" cmpd="sng" algn="ctr">
+                      <a:noFill/>
+                    </a:lnR>
+                    <a:lnT w="0" cap="flat" cmpd="sng" algn="ctr">
+                      <a:noFill/>
+                    </a:lnT>
+                    <a:lnB w="9525" cap="flat" cmpd="sng" algn="ctr">
+                      <a:solidFill>
+                        <a:srgbClr val="E1E0D9"/>
+                      </a:solidFill>
+                      <a:prstDash val="solid"/>
+                      <a:round/>
+                      <a:headEnd type="none" w="med" len="med"/>
+                      <a:tailEnd type="none" w="med" len="med"/>
+                    </a:lnB>
+                  </a:tcPr>
+                </a:tc>
+                <a:tc>
+                  <a:txBody>
+                    <a:bodyPr/>
+                    <a:lstStyle/>
+                    <a:p>
+                      <a:pPr algn="r" indent="0" marL="0">
+                        <a:buNone/>
+                      </a:pPr>
+                      <a:r>
+                        <a:rPr lang="en-US" sz="950" dirty="0">
+                          <a:solidFill>
+                            <a:srgbClr val="0B0B0B"/>
+                          </a:solidFill>
+                          <a:latin typeface="Arial" pitchFamily="34" charset="0"/>
+                          <a:ea typeface="Arial" pitchFamily="34" charset="-122"/>
+                          <a:cs typeface="Arial" pitchFamily="34" charset="-120"/>
+                        </a:rPr>
+                        <a:t>X.X%</a:t>
+                      </a:r>
+                      <a:endParaRPr lang="en-US" sz="950" dirty="0">
+                        <a:latin typeface="Arial" charset="0"/>
+                        <a:ea typeface="Arial" charset="0"/>
+                        <a:cs typeface="Arial" charset="0"/>
+                      </a:endParaRPr>
+                    </a:p>
+                  </a:txBody>
+                  <a:tcPr marL="27432" marR="91440" marT="18288" marB="18288" anchor="ctr">
                     <a:lnL w="0" cap="flat" cmpd="sng" algn="ctr">
                       <a:noFill/>
                     </a:lnL>
@@ -3637,7 +3920,54 @@
                       </a:endParaRPr>
                     </a:p>
                   </a:txBody>
-                  <a:tcPr marL="109728" marR="27432" marT="18288" marB="18288" anchor="ctr">
+                  <a:tcPr marL="54864" marR="27432" marT="18288" marB="18288" anchor="ctr">
+                    <a:lnL w="0" cap="flat" cmpd="sng" algn="ctr">
+                      <a:noFill/>
+                    </a:lnL>
+                    <a:lnR w="0" cap="flat" cmpd="sng" algn="ctr">
+                      <a:noFill/>
+                    </a:lnR>
+                    <a:lnT w="0" cap="flat" cmpd="sng" algn="ctr">
+                      <a:noFill/>
+                    </a:lnT>
+                    <a:lnB w="9525" cap="flat" cmpd="sng" algn="ctr">
+                      <a:solidFill>
+                        <a:srgbClr val="E1E0D9"/>
+                      </a:solidFill>
+                      <a:prstDash val="solid"/>
+                      <a:round/>
+                      <a:headEnd type="none" w="med" len="med"/>
+                      <a:tailEnd type="none" w="med" len="med"/>
+                    </a:lnB>
+                  </a:tcPr>
+                </a:tc>
+                <a:tc>
+                  <a:txBody>
+                    <a:bodyPr/>
+                    <a:lstStyle/>
+                    <a:p>
+                      <a:pPr algn="r" indent="0" marL="0">
+                        <a:buNone/>
+                      </a:pPr>
+                      <a:r>
+                        <a:rPr lang="en-US" sz="950" dirty="0">
+                          <a:solidFill>
+                            <a:srgbClr val="0B0B0B"/>
+                          </a:solidFill>
+                          <a:latin typeface="Arial" pitchFamily="34" charset="0"/>
+                          <a:ea typeface="Arial" pitchFamily="34" charset="-122"/>
+                          <a:cs typeface="Arial" pitchFamily="34" charset="-120"/>
+                        </a:rPr>
+                        <a:t>X.X%</a:t>
+                      </a:r>
+                      <a:endParaRPr lang="en-US" sz="950" dirty="0">
+                        <a:latin typeface="Arial" charset="0"/>
+                        <a:ea typeface="Arial" charset="0"/>
+                        <a:cs typeface="Arial" charset="0"/>
+                      </a:endParaRPr>
+                    </a:p>
+                  </a:txBody>
+                  <a:tcPr marL="27432" marR="91440" marT="18288" marB="18288" anchor="ctr">
                     <a:lnL w="0" cap="flat" cmpd="sng" algn="ctr">
                       <a:noFill/>
                     </a:lnL>
@@ -3863,7 +4193,54 @@
                       </a:endParaRPr>
                     </a:p>
                   </a:txBody>
-                  <a:tcPr marL="109728" marR="27432" marT="18288" marB="18288" anchor="ctr">
+                  <a:tcPr marL="54864" marR="27432" marT="18288" marB="18288" anchor="ctr">
+                    <a:lnL w="0" cap="flat" cmpd="sng" algn="ctr">
+                      <a:noFill/>
+                    </a:lnL>
+                    <a:lnR w="0" cap="flat" cmpd="sng" algn="ctr">
+                      <a:noFill/>
+                    </a:lnR>
+                    <a:lnT w="0" cap="flat" cmpd="sng" algn="ctr">
+                      <a:noFill/>
+                    </a:lnT>
+                    <a:lnB w="9525" cap="flat" cmpd="sng" algn="ctr">
+                      <a:solidFill>
+                        <a:srgbClr val="E1E0D9"/>
+                      </a:solidFill>
+                      <a:prstDash val="solid"/>
+                      <a:round/>
+                      <a:headEnd type="none" w="med" len="med"/>
+                      <a:tailEnd type="none" w="med" len="med"/>
+                    </a:lnB>
+                  </a:tcPr>
+                </a:tc>
+                <a:tc>
+                  <a:txBody>
+                    <a:bodyPr/>
+                    <a:lstStyle/>
+                    <a:p>
+                      <a:pPr algn="r" indent="0" marL="0">
+                        <a:buNone/>
+                      </a:pPr>
+                      <a:r>
+                        <a:rPr lang="en-US" sz="950" dirty="0">
+                          <a:solidFill>
+                            <a:srgbClr val="0B0B0B"/>
+                          </a:solidFill>
+                          <a:latin typeface="Arial" pitchFamily="34" charset="0"/>
+                          <a:ea typeface="Arial" pitchFamily="34" charset="-122"/>
+                          <a:cs typeface="Arial" pitchFamily="34" charset="-120"/>
+                        </a:rPr>
+                        <a:t>X.X%</a:t>
+                      </a:r>
+                      <a:endParaRPr lang="en-US" sz="950" dirty="0">
+                        <a:latin typeface="Arial" charset="0"/>
+                        <a:ea typeface="Arial" charset="0"/>
+                        <a:cs typeface="Arial" charset="0"/>
+                      </a:endParaRPr>
+                    </a:p>
+                  </a:txBody>
+                  <a:tcPr marL="27432" marR="91440" marT="18288" marB="18288" anchor="ctr">
                     <a:lnL w="0" cap="flat" cmpd="sng" algn="ctr">
                       <a:noFill/>
                     </a:lnL>
@@ -4089,7 +4466,54 @@
                       </a:endParaRPr>
                     </a:p>
                   </a:txBody>
-                  <a:tcPr marL="109728" marR="27432" marT="18288" marB="18288" anchor="ctr">
+                  <a:tcPr marL="54864" marR="27432" marT="18288" marB="18288" anchor="ctr">
+                    <a:lnL w="0" cap="flat" cmpd="sng" algn="ctr">
+                      <a:noFill/>
+                    </a:lnL>
+                    <a:lnR w="0" cap="flat" cmpd="sng" algn="ctr">
+                      <a:noFill/>
+                    </a:lnR>
+                    <a:lnT w="0" cap="flat" cmpd="sng" algn="ctr">
+                      <a:noFill/>
+                    </a:lnT>
+                    <a:lnB w="9525" cap="flat" cmpd="sng" algn="ctr">
+                      <a:solidFill>
+                        <a:srgbClr val="E1E0D9"/>
+                      </a:solidFill>
+                      <a:prstDash val="solid"/>
+                      <a:round/>
+                      <a:headEnd type="none" w="med" len="med"/>
+                      <a:tailEnd type="none" w="med" len="med"/>
+                    </a:lnB>
+                  </a:tcPr>
+                </a:tc>
+                <a:tc>
+                  <a:txBody>
+                    <a:bodyPr/>
+                    <a:lstStyle/>
+                    <a:p>
+                      <a:pPr algn="r" indent="0" marL="0">
+                        <a:buNone/>
+                      </a:pPr>
+                      <a:r>
+                        <a:rPr lang="en-US" sz="950" dirty="0">
+                          <a:solidFill>
+                            <a:srgbClr val="0B0B0B"/>
+                          </a:solidFill>
+                          <a:latin typeface="Arial" pitchFamily="34" charset="0"/>
+                          <a:ea typeface="Arial" pitchFamily="34" charset="-122"/>
+                          <a:cs typeface="Arial" pitchFamily="34" charset="-120"/>
+                        </a:rPr>
+                        <a:t>X.X%</a:t>
+                      </a:r>
+                      <a:endParaRPr lang="en-US" sz="950" dirty="0">
+                        <a:latin typeface="Arial" charset="0"/>
+                        <a:ea typeface="Arial" charset="0"/>
+                        <a:cs typeface="Arial" charset="0"/>
+                      </a:endParaRPr>
+                    </a:p>
+                  </a:txBody>
+                  <a:tcPr marL="27432" marR="91440" marT="18288" marB="18288" anchor="ctr">
                     <a:lnL w="0" cap="flat" cmpd="sng" algn="ctr">
                       <a:noFill/>
                     </a:lnL>
@@ -4315,7 +4739,54 @@
                       </a:endParaRPr>
                     </a:p>
                   </a:txBody>
-                  <a:tcPr marL="109728" marR="27432" marT="18288" marB="18288" anchor="ctr">
+                  <a:tcPr marL="54864" marR="27432" marT="18288" marB="18288" anchor="ctr">
+                    <a:lnL w="0" cap="flat" cmpd="sng" algn="ctr">
+                      <a:noFill/>
+                    </a:lnL>
+                    <a:lnR w="0" cap="flat" cmpd="sng" algn="ctr">
+                      <a:noFill/>
+                    </a:lnR>
+                    <a:lnT w="0" cap="flat" cmpd="sng" algn="ctr">
+                      <a:noFill/>
+                    </a:lnT>
+                    <a:lnB w="9525" cap="flat" cmpd="sng" algn="ctr">
+                      <a:solidFill>
+                        <a:srgbClr val="E1E0D9"/>
+                      </a:solidFill>
+                      <a:prstDash val="solid"/>
+                      <a:round/>
+                      <a:headEnd type="none" w="med" len="med"/>
+                      <a:tailEnd type="none" w="med" len="med"/>
+                    </a:lnB>
+                  </a:tcPr>
+                </a:tc>
+                <a:tc>
+                  <a:txBody>
+                    <a:bodyPr/>
+                    <a:lstStyle/>
+                    <a:p>
+                      <a:pPr algn="r" indent="0" marL="0">
+                        <a:buNone/>
+                      </a:pPr>
+                      <a:r>
+                        <a:rPr lang="en-US" sz="950" dirty="0">
+                          <a:solidFill>
+                            <a:srgbClr val="0B0B0B"/>
+                          </a:solidFill>
+                          <a:latin typeface="Arial" pitchFamily="34" charset="0"/>
+                          <a:ea typeface="Arial" pitchFamily="34" charset="-122"/>
+                          <a:cs typeface="Arial" pitchFamily="34" charset="-120"/>
+                        </a:rPr>
+                        <a:t>X.X%</a:t>
+                      </a:r>
+                      <a:endParaRPr lang="en-US" sz="950" dirty="0">
+                        <a:latin typeface="Arial" charset="0"/>
+                        <a:ea typeface="Arial" charset="0"/>
+                        <a:cs typeface="Arial" charset="0"/>
+                      </a:endParaRPr>
+                    </a:p>
+                  </a:txBody>
+                  <a:tcPr marL="27432" marR="91440" marT="18288" marB="18288" anchor="ctr">
                     <a:lnL w="0" cap="flat" cmpd="sng" algn="ctr">
                       <a:noFill/>
                     </a:lnL>
@@ -4541,7 +5012,54 @@
                       </a:endParaRPr>
                     </a:p>
                   </a:txBody>
-                  <a:tcPr marL="109728" marR="27432" marT="18288" marB="18288" anchor="ctr">
+                  <a:tcPr marL="54864" marR="27432" marT="18288" marB="18288" anchor="ctr">
+                    <a:lnL w="0" cap="flat" cmpd="sng" algn="ctr">
+                      <a:noFill/>
+                    </a:lnL>
+                    <a:lnR w="0" cap="flat" cmpd="sng" algn="ctr">
+                      <a:noFill/>
+                    </a:lnR>
+                    <a:lnT w="0" cap="flat" cmpd="sng" algn="ctr">
+                      <a:noFill/>
+                    </a:lnT>
+                    <a:lnB w="9525" cap="flat" cmpd="sng" algn="ctr">
+                      <a:solidFill>
+                        <a:srgbClr val="E1E0D9"/>
+                      </a:solidFill>
+                      <a:prstDash val="solid"/>
+                      <a:round/>
+                      <a:headEnd type="none" w="med" len="med"/>
+                      <a:tailEnd type="none" w="med" len="med"/>
+                    </a:lnB>
+                  </a:tcPr>
+                </a:tc>
+                <a:tc>
+                  <a:txBody>
+                    <a:bodyPr/>
+                    <a:lstStyle/>
+                    <a:p>
+                      <a:pPr algn="r" indent="0" marL="0">
+                        <a:buNone/>
+                      </a:pPr>
+                      <a:r>
+                        <a:rPr lang="en-US" sz="950" dirty="0">
+                          <a:solidFill>
+                            <a:srgbClr val="0B0B0B"/>
+                          </a:solidFill>
+                          <a:latin typeface="Arial" pitchFamily="34" charset="0"/>
+                          <a:ea typeface="Arial" pitchFamily="34" charset="-122"/>
+                          <a:cs typeface="Arial" pitchFamily="34" charset="-120"/>
+                        </a:rPr>
+                        <a:t>X.X%</a:t>
+                      </a:r>
+                      <a:endParaRPr lang="en-US" sz="950" dirty="0">
+                        <a:latin typeface="Arial" charset="0"/>
+                        <a:ea typeface="Arial" charset="0"/>
+                        <a:cs typeface="Arial" charset="0"/>
+                      </a:endParaRPr>
+                    </a:p>
+                  </a:txBody>
+                  <a:tcPr marL="27432" marR="91440" marT="18288" marB="18288" anchor="ctr">
                     <a:lnL w="0" cap="flat" cmpd="sng" algn="ctr">
                       <a:noFill/>
                     </a:lnL>
@@ -4767,7 +5285,54 @@
                       </a:endParaRPr>
                     </a:p>
                   </a:txBody>
-                  <a:tcPr marL="109728" marR="27432" marT="18288" marB="18288" anchor="ctr">
+                  <a:tcPr marL="54864" marR="27432" marT="18288" marB="18288" anchor="ctr">
+                    <a:lnL w="0" cap="flat" cmpd="sng" algn="ctr">
+                      <a:noFill/>
+                    </a:lnL>
+                    <a:lnR w="0" cap="flat" cmpd="sng" algn="ctr">
+                      <a:noFill/>
+                    </a:lnR>
+                    <a:lnT w="0" cap="flat" cmpd="sng" algn="ctr">
+                      <a:noFill/>
+                    </a:lnT>
+                    <a:lnB w="9525" cap="flat" cmpd="sng" algn="ctr">
+                      <a:solidFill>
+                        <a:srgbClr val="E1E0D9"/>
+                      </a:solidFill>
+                      <a:prstDash val="solid"/>
+                      <a:round/>
+                      <a:headEnd type="none" w="med" len="med"/>
+                      <a:tailEnd type="none" w="med" len="med"/>
+                    </a:lnB>
+                  </a:tcPr>
+                </a:tc>
+                <a:tc>
+                  <a:txBody>
+                    <a:bodyPr/>
+                    <a:lstStyle/>
+                    <a:p>
+                      <a:pPr algn="r" indent="0" marL="0">
+                        <a:buNone/>
+                      </a:pPr>
+                      <a:r>
+                        <a:rPr lang="en-US" sz="950" dirty="0">
+                          <a:solidFill>
+                            <a:srgbClr val="0B0B0B"/>
+                          </a:solidFill>
+                          <a:latin typeface="Arial" pitchFamily="34" charset="0"/>
+                          <a:ea typeface="Arial" pitchFamily="34" charset="-122"/>
+                          <a:cs typeface="Arial" pitchFamily="34" charset="-120"/>
+                        </a:rPr>
+                        <a:t>X.X%</a:t>
+                      </a:r>
+                      <a:endParaRPr lang="en-US" sz="950" dirty="0">
+                        <a:latin typeface="Arial" charset="0"/>
+                        <a:ea typeface="Arial" charset="0"/>
+                        <a:cs typeface="Arial" charset="0"/>
+                      </a:endParaRPr>
+                    </a:p>
+                  </a:txBody>
+                  <a:tcPr marL="27432" marR="91440" marT="18288" marB="18288" anchor="ctr">
                     <a:lnL w="0" cap="flat" cmpd="sng" algn="ctr">
                       <a:noFill/>
                     </a:lnL>
@@ -4993,7 +5558,54 @@
                       </a:endParaRPr>
                     </a:p>
                   </a:txBody>
-                  <a:tcPr marL="109728" marR="27432" marT="18288" marB="18288" anchor="ctr">
+                  <a:tcPr marL="54864" marR="27432" marT="18288" marB="18288" anchor="ctr">
+                    <a:lnL w="0" cap="flat" cmpd="sng" algn="ctr">
+                      <a:noFill/>
+                    </a:lnL>
+                    <a:lnR w="0" cap="flat" cmpd="sng" algn="ctr">
+                      <a:noFill/>
+                    </a:lnR>
+                    <a:lnT w="0" cap="flat" cmpd="sng" algn="ctr">
+                      <a:noFill/>
+                    </a:lnT>
+                    <a:lnB w="9525" cap="flat" cmpd="sng" algn="ctr">
+                      <a:solidFill>
+                        <a:srgbClr val="E1E0D9"/>
+                      </a:solidFill>
+                      <a:prstDash val="solid"/>
+                      <a:round/>
+                      <a:headEnd type="none" w="med" len="med"/>
+                      <a:tailEnd type="none" w="med" len="med"/>
+                    </a:lnB>
+                  </a:tcPr>
+                </a:tc>
+                <a:tc>
+                  <a:txBody>
+                    <a:bodyPr/>
+                    <a:lstStyle/>
+                    <a:p>
+                      <a:pPr algn="r" indent="0" marL="0">
+                        <a:buNone/>
+                      </a:pPr>
+                      <a:r>
+                        <a:rPr lang="en-US" sz="950" dirty="0">
+                          <a:solidFill>
+                            <a:srgbClr val="0B0B0B"/>
+                          </a:solidFill>
+                          <a:latin typeface="Arial" pitchFamily="34" charset="0"/>
+                          <a:ea typeface="Arial" pitchFamily="34" charset="-122"/>
+                          <a:cs typeface="Arial" pitchFamily="34" charset="-120"/>
+                        </a:rPr>
+                        <a:t>X.X%</a:t>
+                      </a:r>
+                      <a:endParaRPr lang="en-US" sz="950" dirty="0">
+                        <a:latin typeface="Arial" charset="0"/>
+                        <a:ea typeface="Arial" charset="0"/>
+                        <a:cs typeface="Arial" charset="0"/>
+                      </a:endParaRPr>
+                    </a:p>
+                  </a:txBody>
+                  <a:tcPr marL="27432" marR="91440" marT="18288" marB="18288" anchor="ctr">
                     <a:lnL w="0" cap="flat" cmpd="sng" algn="ctr">
                       <a:noFill/>
                     </a:lnL>
@@ -5219,7 +5831,54 @@
                       </a:endParaRPr>
                     </a:p>
                   </a:txBody>
-                  <a:tcPr marL="109728" marR="27432" marT="18288" marB="18288" anchor="ctr">
+                  <a:tcPr marL="54864" marR="27432" marT="18288" marB="18288" anchor="ctr">
+                    <a:lnL w="0" cap="flat" cmpd="sng" algn="ctr">
+                      <a:noFill/>
+                    </a:lnL>
+                    <a:lnR w="0" cap="flat" cmpd="sng" algn="ctr">
+                      <a:noFill/>
+                    </a:lnR>
+                    <a:lnT w="0" cap="flat" cmpd="sng" algn="ctr">
+                      <a:noFill/>
+                    </a:lnT>
+                    <a:lnB w="9525" cap="flat" cmpd="sng" algn="ctr">
+                      <a:solidFill>
+                        <a:srgbClr val="E1E0D9"/>
+                      </a:solidFill>
+                      <a:prstDash val="solid"/>
+                      <a:round/>
+                      <a:headEnd type="none" w="med" len="med"/>
+                      <a:tailEnd type="none" w="med" len="med"/>
+                    </a:lnB>
+                  </a:tcPr>
+                </a:tc>
+                <a:tc>
+                  <a:txBody>
+                    <a:bodyPr/>
+                    <a:lstStyle/>
+                    <a:p>
+                      <a:pPr algn="r" indent="0" marL="0">
+                        <a:buNone/>
+                      </a:pPr>
+                      <a:r>
+                        <a:rPr lang="en-US" sz="950" dirty="0">
+                          <a:solidFill>
+                            <a:srgbClr val="0B0B0B"/>
+                          </a:solidFill>
+                          <a:latin typeface="Arial" pitchFamily="34" charset="0"/>
+                          <a:ea typeface="Arial" pitchFamily="34" charset="-122"/>
+                          <a:cs typeface="Arial" pitchFamily="34" charset="-120"/>
+                        </a:rPr>
+                        <a:t>X.X%</a:t>
+                      </a:r>
+                      <a:endParaRPr lang="en-US" sz="950" dirty="0">
+                        <a:latin typeface="Arial" charset="0"/>
+                        <a:ea typeface="Arial" charset="0"/>
+                        <a:cs typeface="Arial" charset="0"/>
+                      </a:endParaRPr>
+                    </a:p>
+                  </a:txBody>
+                  <a:tcPr marL="27432" marR="91440" marT="18288" marB="18288" anchor="ctr">
                     <a:lnL w="0" cap="flat" cmpd="sng" algn="ctr">
                       <a:noFill/>
                     </a:lnL>
@@ -5253,7 +5912,7 @@
         </p:nvSpPr>
         <p:spPr>
           <a:xfrm>
-            <a:off x="2624328" y="2887218"/>
+            <a:off x="1828800" y="2887218"/>
             <a:ext cx="877824" cy="219456"/>
           </a:xfrm>
           <a:prstGeom prst="roundRect">
@@ -5275,7 +5934,7 @@
         </p:nvSpPr>
         <p:spPr>
           <a:xfrm>
-            <a:off x="2624328" y="2887218"/>
+            <a:off x="1828800" y="2887218"/>
             <a:ext cx="877824" cy="219456"/>
           </a:xfrm>
           <a:prstGeom prst="rect">
@@ -5328,7 +5987,7 @@
         </p:nvSpPr>
         <p:spPr>
           <a:xfrm>
-            <a:off x="2624328" y="3230118"/>
+            <a:off x="1828800" y="3230118"/>
             <a:ext cx="877824" cy="219456"/>
           </a:xfrm>
           <a:prstGeom prst="roundRect">
@@ -5350,7 +6009,7 @@
         </p:nvSpPr>
         <p:spPr>
           <a:xfrm>
-            <a:off x="2624328" y="3230118"/>
+            <a:off x="1828800" y="3230118"/>
             <a:ext cx="877824" cy="219456"/>
           </a:xfrm>
           <a:prstGeom prst="rect">
@@ -5403,7 +6062,7 @@
         </p:nvSpPr>
         <p:spPr>
           <a:xfrm>
-            <a:off x="2624328" y="3573018"/>
+            <a:off x="1828800" y="3573018"/>
             <a:ext cx="877824" cy="219456"/>
           </a:xfrm>
           <a:prstGeom prst="roundRect">
@@ -5425,7 +6084,7 @@
         </p:nvSpPr>
         <p:spPr>
           <a:xfrm>
-            <a:off x="2624328" y="3573018"/>
+            <a:off x="1828800" y="3573018"/>
             <a:ext cx="877824" cy="219456"/>
           </a:xfrm>
           <a:prstGeom prst="rect">
@@ -5478,7 +6137,7 @@
         </p:nvSpPr>
         <p:spPr>
           <a:xfrm>
-            <a:off x="2624328" y="3915918"/>
+            <a:off x="1828800" y="3915918"/>
             <a:ext cx="877824" cy="219456"/>
           </a:xfrm>
           <a:prstGeom prst="roundRect">
@@ -5500,7 +6159,7 @@
         </p:nvSpPr>
         <p:spPr>
           <a:xfrm>
-            <a:off x="2624328" y="3915918"/>
+            <a:off x="1828800" y="3915918"/>
             <a:ext cx="877824" cy="219456"/>
           </a:xfrm>
           <a:prstGeom prst="rect">
@@ -5553,7 +6212,7 @@
         </p:nvSpPr>
         <p:spPr>
           <a:xfrm>
-            <a:off x="2624328" y="4258818"/>
+            <a:off x="1828800" y="4258818"/>
             <a:ext cx="877824" cy="219456"/>
           </a:xfrm>
           <a:prstGeom prst="roundRect">
@@ -5575,7 +6234,7 @@
         </p:nvSpPr>
         <p:spPr>
           <a:xfrm>
-            <a:off x="2624328" y="4258818"/>
+            <a:off x="1828800" y="4258818"/>
             <a:ext cx="877824" cy="219456"/>
           </a:xfrm>
           <a:prstGeom prst="rect">
@@ -5628,7 +6287,7 @@
         </p:nvSpPr>
         <p:spPr>
           <a:xfrm>
-            <a:off x="2624328" y="4601718"/>
+            <a:off x="1828800" y="4601718"/>
             <a:ext cx="877824" cy="219456"/>
           </a:xfrm>
           <a:prstGeom prst="roundRect">
@@ -5650,7 +6309,7 @@
         </p:nvSpPr>
         <p:spPr>
           <a:xfrm>
-            <a:off x="2624328" y="4601718"/>
+            <a:off x="1828800" y="4601718"/>
             <a:ext cx="877824" cy="219456"/>
           </a:xfrm>
           <a:prstGeom prst="rect">
@@ -5703,7 +6362,7 @@
         </p:nvSpPr>
         <p:spPr>
           <a:xfrm>
-            <a:off x="2624328" y="4944618"/>
+            <a:off x="1828800" y="4944618"/>
             <a:ext cx="987552" cy="219456"/>
           </a:xfrm>
           <a:prstGeom prst="roundRect">
@@ -5725,7 +6384,7 @@
         </p:nvSpPr>
         <p:spPr>
           <a:xfrm>
-            <a:off x="2624328" y="4944618"/>
+            <a:off x="1828800" y="4944618"/>
             <a:ext cx="987552" cy="219456"/>
           </a:xfrm>
           <a:prstGeom prst="rect">
@@ -5778,7 +6437,7 @@
         </p:nvSpPr>
         <p:spPr>
           <a:xfrm>
-            <a:off x="2624328" y="5287518"/>
+            <a:off x="1828800" y="5287518"/>
             <a:ext cx="987552" cy="219456"/>
           </a:xfrm>
           <a:prstGeom prst="roundRect">
@@ -5800,7 +6459,7 @@
         </p:nvSpPr>
         <p:spPr>
           <a:xfrm>
-            <a:off x="2624328" y="5287518"/>
+            <a:off x="1828800" y="5287518"/>
             <a:ext cx="987552" cy="219456"/>
           </a:xfrm>
           <a:prstGeom prst="rect">
@@ -5853,7 +6512,7 @@
         </p:nvSpPr>
         <p:spPr>
           <a:xfrm>
-            <a:off x="2624328" y="5630418"/>
+            <a:off x="1828800" y="5630418"/>
             <a:ext cx="987552" cy="219456"/>
           </a:xfrm>
           <a:prstGeom prst="roundRect">
@@ -5875,7 +6534,7 @@
         </p:nvSpPr>
         <p:spPr>
           <a:xfrm>
-            <a:off x="2624328" y="5630418"/>
+            <a:off x="1828800" y="5630418"/>
             <a:ext cx="987552" cy="219456"/>
           </a:xfrm>
           <a:prstGeom prst="rect">
@@ -5928,7 +6587,7 @@
         </p:nvSpPr>
         <p:spPr>
           <a:xfrm>
-            <a:off x="2624328" y="5973318"/>
+            <a:off x="1828800" y="5973318"/>
             <a:ext cx="694944" cy="219456"/>
           </a:xfrm>
           <a:prstGeom prst="roundRect">
@@ -5950,7 +6609,7 @@
         </p:nvSpPr>
         <p:spPr>
           <a:xfrm>
-            <a:off x="2624328" y="5973318"/>
+            <a:off x="1828800" y="5973318"/>
             <a:ext cx="694944" cy="219456"/>
           </a:xfrm>
           <a:prstGeom prst="rect">
@@ -6003,7 +6662,7 @@
         </p:nvSpPr>
         <p:spPr>
           <a:xfrm>
-            <a:off x="2624328" y="6316218"/>
+            <a:off x="1828800" y="6316218"/>
             <a:ext cx="694944" cy="219456"/>
           </a:xfrm>
           <a:prstGeom prst="roundRect">
@@ -6025,7 +6684,7 @@
         </p:nvSpPr>
         <p:spPr>
           <a:xfrm>
-            <a:off x="2624328" y="6316218"/>
+            <a:off x="1828800" y="6316218"/>
             <a:ext cx="694944" cy="219456"/>
           </a:xfrm>
           <a:prstGeom prst="rect">
@@ -6078,7 +6737,7 @@
         </p:nvSpPr>
         <p:spPr>
           <a:xfrm>
-            <a:off x="2624328" y="6659118"/>
+            <a:off x="1828800" y="6659118"/>
             <a:ext cx="694944" cy="219456"/>
           </a:xfrm>
           <a:prstGeom prst="roundRect">
@@ -6100,7 +6759,7 @@
         </p:nvSpPr>
         <p:spPr>
           <a:xfrm>
-            <a:off x="2624328" y="6659118"/>
+            <a:off x="1828800" y="6659118"/>
             <a:ext cx="694944" cy="219456"/>
           </a:xfrm>
           <a:prstGeom prst="rect">
@@ -6153,7 +6812,7 @@
         </p:nvSpPr>
         <p:spPr>
           <a:xfrm>
-            <a:off x="2624328" y="7002018"/>
+            <a:off x="1828800" y="7002018"/>
             <a:ext cx="694944" cy="219456"/>
           </a:xfrm>
           <a:prstGeom prst="roundRect">
@@ -6175,7 +6834,7 @@
         </p:nvSpPr>
         <p:spPr>
           <a:xfrm>
-            <a:off x="2624328" y="7002018"/>
+            <a:off x="1828800" y="7002018"/>
             <a:ext cx="694944" cy="219456"/>
           </a:xfrm>
           <a:prstGeom prst="rect">
@@ -6228,7 +6887,7 @@
         </p:nvSpPr>
         <p:spPr>
           <a:xfrm>
-            <a:off x="5742432" y="2162556"/>
+            <a:off x="5166360" y="2162556"/>
             <a:ext cx="274320" cy="187452"/>
           </a:xfrm>
           <a:prstGeom prst="roundRect">
@@ -6255,7 +6914,7 @@
         </p:nvSpPr>
         <p:spPr>
           <a:xfrm>
-            <a:off x="5827105" y="2203795"/>
+            <a:off x="5251033" y="2203795"/>
             <a:ext cx="104973" cy="104973"/>
           </a:xfrm>
           <a:prstGeom prst="ellipse">
@@ -6275,7 +6934,7 @@
         </p:nvSpPr>
         <p:spPr>
           <a:xfrm>
-            <a:off x="5827105" y="2203795"/>
+            <a:off x="5251033" y="2203795"/>
             <a:ext cx="104973" cy="104973"/>
           </a:xfrm>
           <a:prstGeom prst="pie">
@@ -6298,7 +6957,7 @@
         </p:nvSpPr>
         <p:spPr>
           <a:xfrm>
-            <a:off x="6089904" y="2121408"/>
+            <a:off x="5513832" y="2121408"/>
             <a:ext cx="1463040" cy="274320"/>
           </a:xfrm>
           <a:prstGeom prst="rect">
@@ -6390,8 +7049,8 @@
         </p:nvSpPr>
         <p:spPr>
           <a:xfrm>
-            <a:off x="5742432" y="2459736"/>
-            <a:ext cx="3931920" cy="25603"/>
+            <a:off x="5166360" y="2459736"/>
+            <a:ext cx="4507992" cy="25603"/>
           </a:xfrm>
           <a:prstGeom prst="rect">
             <a:avLst/>
@@ -6417,19 +7076,20 @@
           </p:nvPr>
         </p:nvGraphicFramePr>
         <p:xfrm>
-          <a:off x="5742432" y="2569464"/>
-          <a:ext cx="3931920" cy="914400"/>
+          <a:off x="5166360" y="2569464"/>
+          <a:ext cx="4507992" cy="914400"/>
         </p:xfrm>
         <a:graphic>
           <a:graphicData uri="http://schemas.openxmlformats.org/drawingml/2006/table">
             <a:tbl>
               <a:tblPr/>
               <a:tblGrid>
-                <a:gridCol w="859536"/>
-                <a:gridCol w="585216"/>
-                <a:gridCol w="1060704"/>
-                <a:gridCol w="621792"/>
-                <a:gridCol w="804672"/>
+                <a:gridCol w="832104"/>
+                <a:gridCol w="566928"/>
+                <a:gridCol w="1042416"/>
+                <a:gridCol w="576072"/>
+                <a:gridCol w="749808"/>
+                <a:gridCol w="740664"/>
               </a:tblGrid>
               <a:tr h="256032">
                 <a:tc>
@@ -6441,7 +7101,7 @@
                         <a:buNone/>
                       </a:pPr>
                       <a:r>
-                        <a:rPr lang="en-US" sz="750" b="1" dirty="0">
+                        <a:rPr lang="en-US" sz="700" b="1" dirty="0">
                           <a:solidFill>
                             <a:srgbClr val="898781"/>
                           </a:solidFill>
@@ -6451,7 +7111,7 @@
                         </a:rPr>
                         <a:t>COMPANY</a:t>
                       </a:r>
-                      <a:endParaRPr lang="en-US" sz="750" dirty="0">
+                      <a:endParaRPr lang="en-US" sz="700" dirty="0">
                         <a:latin typeface="Arial" charset="0"/>
                         <a:ea typeface="Arial" charset="0"/>
                         <a:cs typeface="Arial" charset="0"/>
@@ -6488,7 +7148,7 @@
                         <a:buNone/>
                       </a:pPr>
                       <a:r>
-                        <a:rPr lang="en-US" sz="750" b="1" dirty="0">
+                        <a:rPr lang="en-US" sz="700" b="1" dirty="0">
                           <a:solidFill>
                             <a:srgbClr val="898781"/>
                           </a:solidFill>
@@ -6498,7 +7158,7 @@
                         </a:rPr>
                         <a:t>SECTOR</a:t>
                       </a:r>
-                      <a:endParaRPr lang="en-US" sz="750" dirty="0">
+                      <a:endParaRPr lang="en-US" sz="700" dirty="0">
                         <a:latin typeface="Arial" charset="0"/>
                         <a:ea typeface="Arial" charset="0"/>
                         <a:cs typeface="Arial" charset="0"/>
@@ -6535,7 +7195,7 @@
                         <a:buNone/>
                       </a:pPr>
                       <a:r>
-                        <a:rPr lang="en-US" sz="750" b="1" dirty="0">
+                        <a:rPr lang="en-US" sz="700" b="1" dirty="0">
                           <a:solidFill>
                             <a:srgbClr val="898781"/>
                           </a:solidFill>
@@ -6545,7 +7205,7 @@
                         </a:rPr>
                         <a:t>STAGE</a:t>
                       </a:r>
-                      <a:endParaRPr lang="en-US" sz="750" dirty="0">
+                      <a:endParaRPr lang="en-US" sz="700" dirty="0">
                         <a:latin typeface="Arial" charset="0"/>
                         <a:ea typeface="Arial" charset="0"/>
                         <a:cs typeface="Arial" charset="0"/>
@@ -6582,7 +7242,7 @@
                         <a:buNone/>
                       </a:pPr>
                       <a:r>
-                        <a:rPr lang="en-US" sz="750" b="1" dirty="0">
+                        <a:rPr lang="en-US" sz="700" b="1" dirty="0">
                           <a:solidFill>
                             <a:srgbClr val="898781"/>
                           </a:solidFill>
@@ -6592,7 +7252,7 @@
                         </a:rPr>
                         <a:t>DEAL SIZE</a:t>
                       </a:r>
-                      <a:endParaRPr lang="en-US" sz="750" dirty="0">
+                      <a:endParaRPr lang="en-US" sz="700" dirty="0">
                         <a:latin typeface="Arial" charset="0"/>
                         <a:ea typeface="Arial" charset="0"/>
                         <a:cs typeface="Arial" charset="0"/>
@@ -6629,7 +7289,7 @@
                         <a:buNone/>
                       </a:pPr>
                       <a:r>
-                        <a:rPr lang="en-US" sz="750" b="1" dirty="0">
+                        <a:rPr lang="en-US" sz="700" b="1" dirty="0">
                           <a:solidFill>
                             <a:srgbClr val="898781"/>
                           </a:solidFill>
@@ -6639,14 +7299,61 @@
                         </a:rPr>
                         <a:t>OWNER’S REP</a:t>
                       </a:r>
-                      <a:endParaRPr lang="en-US" sz="750" dirty="0">
-                        <a:latin typeface="Arial" charset="0"/>
-                        <a:ea typeface="Arial" charset="0"/>
-                        <a:cs typeface="Arial" charset="0"/>
-                      </a:endParaRPr>
-                    </a:p>
-                  </a:txBody>
-                  <a:tcPr marL="91440" marR="27432" marT="18288" marB="18288" anchor="ctr">
+                      <a:endParaRPr lang="en-US" sz="700" dirty="0">
+                        <a:latin typeface="Arial" charset="0"/>
+                        <a:ea typeface="Arial" charset="0"/>
+                        <a:cs typeface="Arial" charset="0"/>
+                      </a:endParaRPr>
+                    </a:p>
+                  </a:txBody>
+                  <a:tcPr marL="54864" marR="27432" marT="18288" marB="18288" anchor="ctr">
+                    <a:lnL w="0" cap="flat" cmpd="sng" algn="ctr">
+                      <a:noFill/>
+                    </a:lnL>
+                    <a:lnR w="0" cap="flat" cmpd="sng" algn="ctr">
+                      <a:noFill/>
+                    </a:lnR>
+                    <a:lnT w="0" cap="flat" cmpd="sng" algn="ctr">
+                      <a:noFill/>
+                    </a:lnT>
+                    <a:lnB w="15875" cap="flat" cmpd="sng" algn="ctr">
+                      <a:solidFill>
+                        <a:srgbClr val="E1E0D9"/>
+                      </a:solidFill>
+                      <a:prstDash val="solid"/>
+                      <a:round/>
+                      <a:headEnd type="none" w="med" len="med"/>
+                      <a:tailEnd type="none" w="med" len="med"/>
+                    </a:lnB>
+                  </a:tcPr>
+                </a:tc>
+                <a:tc>
+                  <a:txBody>
+                    <a:bodyPr/>
+                    <a:lstStyle/>
+                    <a:p>
+                      <a:pPr algn="r" indent="0" marL="0">
+                        <a:buNone/>
+                      </a:pPr>
+                      <a:r>
+                        <a:rPr lang="en-US" sz="700" b="1" dirty="0">
+                          <a:solidFill>
+                            <a:srgbClr val="898781"/>
+                          </a:solidFill>
+                          <a:latin typeface="Arial" pitchFamily="34" charset="0"/>
+                          <a:ea typeface="Arial" pitchFamily="34" charset="-122"/>
+                          <a:cs typeface="Arial" pitchFamily="34" charset="-120"/>
+                        </a:rPr>
+                        <a:t>WARRANTS %</a:t>
+                      </a:r>
+                      <a:endParaRPr lang="en-US" sz="700" dirty="0">
+                        <a:latin typeface="Arial" charset="0"/>
+                        <a:ea typeface="Arial" charset="0"/>
+                        <a:cs typeface="Arial" charset="0"/>
+                      </a:endParaRPr>
+                    </a:p>
+                  </a:txBody>
+                  <a:tcPr marL="27432" marR="73152" marT="18288" marB="18288" anchor="ctr">
                     <a:lnL w="0" cap="flat" cmpd="sng" algn="ctr">
                       <a:noFill/>
                     </a:lnL>
@@ -6872,7 +7579,54 @@
                       </a:endParaRPr>
                     </a:p>
                   </a:txBody>
-                  <a:tcPr marL="109728" marR="27432" marT="18288" marB="18288" anchor="ctr">
+                  <a:tcPr marL="54864" marR="27432" marT="18288" marB="18288" anchor="ctr">
+                    <a:lnL w="0" cap="flat" cmpd="sng" algn="ctr">
+                      <a:noFill/>
+                    </a:lnL>
+                    <a:lnR w="0" cap="flat" cmpd="sng" algn="ctr">
+                      <a:noFill/>
+                    </a:lnR>
+                    <a:lnT w="0" cap="flat" cmpd="sng" algn="ctr">
+                      <a:noFill/>
+                    </a:lnT>
+                    <a:lnB w="9525" cap="flat" cmpd="sng" algn="ctr">
+                      <a:solidFill>
+                        <a:srgbClr val="E1E0D9"/>
+                      </a:solidFill>
+                      <a:prstDash val="solid"/>
+                      <a:round/>
+                      <a:headEnd type="none" w="med" len="med"/>
+                      <a:tailEnd type="none" w="med" len="med"/>
+                    </a:lnB>
+                  </a:tcPr>
+                </a:tc>
+                <a:tc>
+                  <a:txBody>
+                    <a:bodyPr/>
+                    <a:lstStyle/>
+                    <a:p>
+                      <a:pPr algn="r" indent="0" marL="0">
+                        <a:buNone/>
+                      </a:pPr>
+                      <a:r>
+                        <a:rPr lang="en-US" sz="950" dirty="0">
+                          <a:solidFill>
+                            <a:srgbClr val="0B0B0B"/>
+                          </a:solidFill>
+                          <a:latin typeface="Arial" pitchFamily="34" charset="0"/>
+                          <a:ea typeface="Arial" pitchFamily="34" charset="-122"/>
+                          <a:cs typeface="Arial" pitchFamily="34" charset="-120"/>
+                        </a:rPr>
+                        <a:t>X.X%</a:t>
+                      </a:r>
+                      <a:endParaRPr lang="en-US" sz="950" dirty="0">
+                        <a:latin typeface="Arial" charset="0"/>
+                        <a:ea typeface="Arial" charset="0"/>
+                        <a:cs typeface="Arial" charset="0"/>
+                      </a:endParaRPr>
+                    </a:p>
+                  </a:txBody>
+                  <a:tcPr marL="27432" marR="91440" marT="18288" marB="18288" anchor="ctr">
                     <a:lnL w="0" cap="flat" cmpd="sng" algn="ctr">
                       <a:noFill/>
                     </a:lnL>
@@ -7098,7 +7852,54 @@
                       </a:endParaRPr>
                     </a:p>
                   </a:txBody>
-                  <a:tcPr marL="109728" marR="27432" marT="18288" marB="18288" anchor="ctr">
+                  <a:tcPr marL="54864" marR="27432" marT="18288" marB="18288" anchor="ctr">
+                    <a:lnL w="0" cap="flat" cmpd="sng" algn="ctr">
+                      <a:noFill/>
+                    </a:lnL>
+                    <a:lnR w="0" cap="flat" cmpd="sng" algn="ctr">
+                      <a:noFill/>
+                    </a:lnR>
+                    <a:lnT w="0" cap="flat" cmpd="sng" algn="ctr">
+                      <a:noFill/>
+                    </a:lnT>
+                    <a:lnB w="9525" cap="flat" cmpd="sng" algn="ctr">
+                      <a:solidFill>
+                        <a:srgbClr val="E1E0D9"/>
+                      </a:solidFill>
+                      <a:prstDash val="solid"/>
+                      <a:round/>
+                      <a:headEnd type="none" w="med" len="med"/>
+                      <a:tailEnd type="none" w="med" len="med"/>
+                    </a:lnB>
+                  </a:tcPr>
+                </a:tc>
+                <a:tc>
+                  <a:txBody>
+                    <a:bodyPr/>
+                    <a:lstStyle/>
+                    <a:p>
+                      <a:pPr algn="r" indent="0" marL="0">
+                        <a:buNone/>
+                      </a:pPr>
+                      <a:r>
+                        <a:rPr lang="en-US" sz="950" dirty="0">
+                          <a:solidFill>
+                            <a:srgbClr val="0B0B0B"/>
+                          </a:solidFill>
+                          <a:latin typeface="Arial" pitchFamily="34" charset="0"/>
+                          <a:ea typeface="Arial" pitchFamily="34" charset="-122"/>
+                          <a:cs typeface="Arial" pitchFamily="34" charset="-120"/>
+                        </a:rPr>
+                        <a:t>X.X%</a:t>
+                      </a:r>
+                      <a:endParaRPr lang="en-US" sz="950" dirty="0">
+                        <a:latin typeface="Arial" charset="0"/>
+                        <a:ea typeface="Arial" charset="0"/>
+                        <a:cs typeface="Arial" charset="0"/>
+                      </a:endParaRPr>
+                    </a:p>
+                  </a:txBody>
+                  <a:tcPr marL="27432" marR="91440" marT="18288" marB="18288" anchor="ctr">
                     <a:lnL w="0" cap="flat" cmpd="sng" algn="ctr">
                       <a:noFill/>
                     </a:lnL>
@@ -7324,7 +8125,54 @@
                       </a:endParaRPr>
                     </a:p>
                   </a:txBody>
-                  <a:tcPr marL="109728" marR="27432" marT="18288" marB="18288" anchor="ctr">
+                  <a:tcPr marL="54864" marR="27432" marT="18288" marB="18288" anchor="ctr">
+                    <a:lnL w="0" cap="flat" cmpd="sng" algn="ctr">
+                      <a:noFill/>
+                    </a:lnL>
+                    <a:lnR w="0" cap="flat" cmpd="sng" algn="ctr">
+                      <a:noFill/>
+                    </a:lnR>
+                    <a:lnT w="0" cap="flat" cmpd="sng" algn="ctr">
+                      <a:noFill/>
+                    </a:lnT>
+                    <a:lnB w="9525" cap="flat" cmpd="sng" algn="ctr">
+                      <a:solidFill>
+                        <a:srgbClr val="E1E0D9"/>
+                      </a:solidFill>
+                      <a:prstDash val="solid"/>
+                      <a:round/>
+                      <a:headEnd type="none" w="med" len="med"/>
+                      <a:tailEnd type="none" w="med" len="med"/>
+                    </a:lnB>
+                  </a:tcPr>
+                </a:tc>
+                <a:tc>
+                  <a:txBody>
+                    <a:bodyPr/>
+                    <a:lstStyle/>
+                    <a:p>
+                      <a:pPr algn="r" indent="0" marL="0">
+                        <a:buNone/>
+                      </a:pPr>
+                      <a:r>
+                        <a:rPr lang="en-US" sz="950" dirty="0">
+                          <a:solidFill>
+                            <a:srgbClr val="0B0B0B"/>
+                          </a:solidFill>
+                          <a:latin typeface="Arial" pitchFamily="34" charset="0"/>
+                          <a:ea typeface="Arial" pitchFamily="34" charset="-122"/>
+                          <a:cs typeface="Arial" pitchFamily="34" charset="-120"/>
+                        </a:rPr>
+                        <a:t>X.X%</a:t>
+                      </a:r>
+                      <a:endParaRPr lang="en-US" sz="950" dirty="0">
+                        <a:latin typeface="Arial" charset="0"/>
+                        <a:ea typeface="Arial" charset="0"/>
+                        <a:cs typeface="Arial" charset="0"/>
+                      </a:endParaRPr>
+                    </a:p>
+                  </a:txBody>
+                  <a:tcPr marL="27432" marR="91440" marT="18288" marB="18288" anchor="ctr">
                     <a:lnL w="0" cap="flat" cmpd="sng" algn="ctr">
                       <a:noFill/>
                     </a:lnL>
@@ -7550,7 +8398,54 @@
                       </a:endParaRPr>
                     </a:p>
                   </a:txBody>
-                  <a:tcPr marL="109728" marR="27432" marT="18288" marB="18288" anchor="ctr">
+                  <a:tcPr marL="54864" marR="27432" marT="18288" marB="18288" anchor="ctr">
+                    <a:lnL w="0" cap="flat" cmpd="sng" algn="ctr">
+                      <a:noFill/>
+                    </a:lnL>
+                    <a:lnR w="0" cap="flat" cmpd="sng" algn="ctr">
+                      <a:noFill/>
+                    </a:lnR>
+                    <a:lnT w="0" cap="flat" cmpd="sng" algn="ctr">
+                      <a:noFill/>
+                    </a:lnT>
+                    <a:lnB w="9525" cap="flat" cmpd="sng" algn="ctr">
+                      <a:solidFill>
+                        <a:srgbClr val="E1E0D9"/>
+                      </a:solidFill>
+                      <a:prstDash val="solid"/>
+                      <a:round/>
+                      <a:headEnd type="none" w="med" len="med"/>
+                      <a:tailEnd type="none" w="med" len="med"/>
+                    </a:lnB>
+                  </a:tcPr>
+                </a:tc>
+                <a:tc>
+                  <a:txBody>
+                    <a:bodyPr/>
+                    <a:lstStyle/>
+                    <a:p>
+                      <a:pPr algn="r" indent="0" marL="0">
+                        <a:buNone/>
+                      </a:pPr>
+                      <a:r>
+                        <a:rPr lang="en-US" sz="950" dirty="0">
+                          <a:solidFill>
+                            <a:srgbClr val="0B0B0B"/>
+                          </a:solidFill>
+                          <a:latin typeface="Arial" pitchFamily="34" charset="0"/>
+                          <a:ea typeface="Arial" pitchFamily="34" charset="-122"/>
+                          <a:cs typeface="Arial" pitchFamily="34" charset="-120"/>
+                        </a:rPr>
+                        <a:t>X.X%</a:t>
+                      </a:r>
+                      <a:endParaRPr lang="en-US" sz="950" dirty="0">
+                        <a:latin typeface="Arial" charset="0"/>
+                        <a:ea typeface="Arial" charset="0"/>
+                        <a:cs typeface="Arial" charset="0"/>
+                      </a:endParaRPr>
+                    </a:p>
+                  </a:txBody>
+                  <a:tcPr marL="27432" marR="91440" marT="18288" marB="18288" anchor="ctr">
                     <a:lnL w="0" cap="flat" cmpd="sng" algn="ctr">
                       <a:noFill/>
                     </a:lnL>
@@ -7776,7 +8671,54 @@
                       </a:endParaRPr>
                     </a:p>
                   </a:txBody>
-                  <a:tcPr marL="109728" marR="27432" marT="18288" marB="18288" anchor="ctr">
+                  <a:tcPr marL="54864" marR="27432" marT="18288" marB="18288" anchor="ctr">
+                    <a:lnL w="0" cap="flat" cmpd="sng" algn="ctr">
+                      <a:noFill/>
+                    </a:lnL>
+                    <a:lnR w="0" cap="flat" cmpd="sng" algn="ctr">
+                      <a:noFill/>
+                    </a:lnR>
+                    <a:lnT w="0" cap="flat" cmpd="sng" algn="ctr">
+                      <a:noFill/>
+                    </a:lnT>
+                    <a:lnB w="9525" cap="flat" cmpd="sng" algn="ctr">
+                      <a:solidFill>
+                        <a:srgbClr val="E1E0D9"/>
+                      </a:solidFill>
+                      <a:prstDash val="solid"/>
+                      <a:round/>
+                      <a:headEnd type="none" w="med" len="med"/>
+                      <a:tailEnd type="none" w="med" len="med"/>
+                    </a:lnB>
+                  </a:tcPr>
+                </a:tc>
+                <a:tc>
+                  <a:txBody>
+                    <a:bodyPr/>
+                    <a:lstStyle/>
+                    <a:p>
+                      <a:pPr algn="r" indent="0" marL="0">
+                        <a:buNone/>
+                      </a:pPr>
+                      <a:r>
+                        <a:rPr lang="en-US" sz="950" dirty="0">
+                          <a:solidFill>
+                            <a:srgbClr val="0B0B0B"/>
+                          </a:solidFill>
+                          <a:latin typeface="Arial" pitchFamily="34" charset="0"/>
+                          <a:ea typeface="Arial" pitchFamily="34" charset="-122"/>
+                          <a:cs typeface="Arial" pitchFamily="34" charset="-120"/>
+                        </a:rPr>
+                        <a:t>X.X%</a:t>
+                      </a:r>
+                      <a:endParaRPr lang="en-US" sz="950" dirty="0">
+                        <a:latin typeface="Arial" charset="0"/>
+                        <a:ea typeface="Arial" charset="0"/>
+                        <a:cs typeface="Arial" charset="0"/>
+                      </a:endParaRPr>
+                    </a:p>
+                  </a:txBody>
+                  <a:tcPr marL="27432" marR="91440" marT="18288" marB="18288" anchor="ctr">
                     <a:lnL w="0" cap="flat" cmpd="sng" algn="ctr">
                       <a:noFill/>
                     </a:lnL>
@@ -8002,7 +8944,54 @@
                       </a:endParaRPr>
                     </a:p>
                   </a:txBody>
-                  <a:tcPr marL="109728" marR="27432" marT="18288" marB="18288" anchor="ctr">
+                  <a:tcPr marL="54864" marR="27432" marT="18288" marB="18288" anchor="ctr">
+                    <a:lnL w="0" cap="flat" cmpd="sng" algn="ctr">
+                      <a:noFill/>
+                    </a:lnL>
+                    <a:lnR w="0" cap="flat" cmpd="sng" algn="ctr">
+                      <a:noFill/>
+                    </a:lnR>
+                    <a:lnT w="0" cap="flat" cmpd="sng" algn="ctr">
+                      <a:noFill/>
+                    </a:lnT>
+                    <a:lnB w="9525" cap="flat" cmpd="sng" algn="ctr">
+                      <a:solidFill>
+                        <a:srgbClr val="E1E0D9"/>
+                      </a:solidFill>
+                      <a:prstDash val="solid"/>
+                      <a:round/>
+                      <a:headEnd type="none" w="med" len="med"/>
+                      <a:tailEnd type="none" w="med" len="med"/>
+                    </a:lnB>
+                  </a:tcPr>
+                </a:tc>
+                <a:tc>
+                  <a:txBody>
+                    <a:bodyPr/>
+                    <a:lstStyle/>
+                    <a:p>
+                      <a:pPr algn="r" indent="0" marL="0">
+                        <a:buNone/>
+                      </a:pPr>
+                      <a:r>
+                        <a:rPr lang="en-US" sz="950" dirty="0">
+                          <a:solidFill>
+                            <a:srgbClr val="0B0B0B"/>
+                          </a:solidFill>
+                          <a:latin typeface="Arial" pitchFamily="34" charset="0"/>
+                          <a:ea typeface="Arial" pitchFamily="34" charset="-122"/>
+                          <a:cs typeface="Arial" pitchFamily="34" charset="-120"/>
+                        </a:rPr>
+                        <a:t>X.X%</a:t>
+                      </a:r>
+                      <a:endParaRPr lang="en-US" sz="950" dirty="0">
+                        <a:latin typeface="Arial" charset="0"/>
+                        <a:ea typeface="Arial" charset="0"/>
+                        <a:cs typeface="Arial" charset="0"/>
+                      </a:endParaRPr>
+                    </a:p>
+                  </a:txBody>
+                  <a:tcPr marL="27432" marR="91440" marT="18288" marB="18288" anchor="ctr">
                     <a:lnL w="0" cap="flat" cmpd="sng" algn="ctr">
                       <a:noFill/>
                     </a:lnL>
@@ -8036,7 +9025,7 @@
         </p:nvSpPr>
         <p:spPr>
           <a:xfrm>
-            <a:off x="7232904" y="2887218"/>
+            <a:off x="6611112" y="2887218"/>
             <a:ext cx="987552" cy="219456"/>
           </a:xfrm>
           <a:prstGeom prst="roundRect">
@@ -8058,7 +9047,7 @@
         </p:nvSpPr>
         <p:spPr>
           <a:xfrm>
-            <a:off x="7232904" y="2887218"/>
+            <a:off x="6611112" y="2887218"/>
             <a:ext cx="987552" cy="219456"/>
           </a:xfrm>
           <a:prstGeom prst="rect">
@@ -8111,7 +9100,7 @@
         </p:nvSpPr>
         <p:spPr>
           <a:xfrm>
-            <a:off x="7232904" y="3230118"/>
+            <a:off x="6611112" y="3230118"/>
             <a:ext cx="987552" cy="219456"/>
           </a:xfrm>
           <a:prstGeom prst="roundRect">
@@ -8133,7 +9122,7 @@
         </p:nvSpPr>
         <p:spPr>
           <a:xfrm>
-            <a:off x="7232904" y="3230118"/>
+            <a:off x="6611112" y="3230118"/>
             <a:ext cx="987552" cy="219456"/>
           </a:xfrm>
           <a:prstGeom prst="rect">
@@ -8186,7 +9175,7 @@
         </p:nvSpPr>
         <p:spPr>
           <a:xfrm>
-            <a:off x="7232904" y="3573018"/>
+            <a:off x="6611112" y="3573018"/>
             <a:ext cx="987552" cy="219456"/>
           </a:xfrm>
           <a:prstGeom prst="roundRect">
@@ -8208,7 +9197,7 @@
         </p:nvSpPr>
         <p:spPr>
           <a:xfrm>
-            <a:off x="7232904" y="3573018"/>
+            <a:off x="6611112" y="3573018"/>
             <a:ext cx="987552" cy="219456"/>
           </a:xfrm>
           <a:prstGeom prst="rect">
@@ -8261,7 +9250,7 @@
         </p:nvSpPr>
         <p:spPr>
           <a:xfrm>
-            <a:off x="7232904" y="3915918"/>
+            <a:off x="6611112" y="3915918"/>
             <a:ext cx="694944" cy="219456"/>
           </a:xfrm>
           <a:prstGeom prst="roundRect">
@@ -8283,7 +9272,7 @@
         </p:nvSpPr>
         <p:spPr>
           <a:xfrm>
-            <a:off x="7232904" y="3915918"/>
+            <a:off x="6611112" y="3915918"/>
             <a:ext cx="694944" cy="219456"/>
           </a:xfrm>
           <a:prstGeom prst="rect">
@@ -8336,7 +9325,7 @@
         </p:nvSpPr>
         <p:spPr>
           <a:xfrm>
-            <a:off x="7232904" y="4258818"/>
+            <a:off x="6611112" y="4258818"/>
             <a:ext cx="694944" cy="219456"/>
           </a:xfrm>
           <a:prstGeom prst="roundRect">
@@ -8358,7 +9347,7 @@
         </p:nvSpPr>
         <p:spPr>
           <a:xfrm>
-            <a:off x="7232904" y="4258818"/>
+            <a:off x="6611112" y="4258818"/>
             <a:ext cx="694944" cy="219456"/>
           </a:xfrm>
           <a:prstGeom prst="rect">
@@ -8411,7 +9400,7 @@
         </p:nvSpPr>
         <p:spPr>
           <a:xfrm>
-            <a:off x="7232904" y="4601718"/>
+            <a:off x="6611112" y="4601718"/>
             <a:ext cx="694944" cy="219456"/>
           </a:xfrm>
           <a:prstGeom prst="roundRect">
@@ -8433,7 +9422,7 @@
         </p:nvSpPr>
         <p:spPr>
           <a:xfrm>
-            <a:off x="7232904" y="4601718"/>
+            <a:off x="6611112" y="4601718"/>
             <a:ext cx="694944" cy="219456"/>
           </a:xfrm>
           <a:prstGeom prst="rect">

</xml_diff>